<commit_message>
Insert system-composition diagram (row 0b) into CDR slide 14
- Removed 33 hand-drawn shapes (IDs 9-41) from slide 14
- Inserted aos_syson.png (General View on Architecture::AerialObservationSystem)
  showing drone : Drone and gcs : GCS with 6 interface connections
- Added presentation/apply_slide14_diagram.py for future diagram swaps
- Saved generated diagram to presentation/assets/diagrams/system_composition.png/svg
- Added *.bak.pptx to .gitignore

This replaces the hand-drawn 'System Composition — Block-Definition View' slide
with a model-derived SysML v2 General View, unblocking task 85 [0.1].
</commit_message>
<xml_diff>
--- a/CDR_Thermal_Surveillance_Drone.pptx
+++ b/CDR_Thermal_Surveillance_Drone.pptx
@@ -12580,60 +12580,14 @@
       </p:sp>
       <p:sp>
         <p:nvSpPr>
-          <p:cNvPr id="9" name="Rectangle 8"/>
-          <p:cNvSpPr/>
-          <p:nvPr/>
-        </p:nvSpPr>
-        <p:spPr>
-          <a:xfrm>
-            <a:off x="4590288" y="1207008"/>
-            <a:ext cx="3017520" cy="621792"/>
-          </a:xfrm>
-          <a:prstGeom prst="rect">
-            <a:avLst/>
-          </a:prstGeom>
-          <a:solidFill>
-            <a:srgbClr val="EAF1F7"/>
-          </a:solidFill>
-          <a:ln w="15875">
-            <a:solidFill>
-              <a:srgbClr val="2E86AB"/>
-            </a:solidFill>
-          </a:ln>
-          <a:effectLst/>
-        </p:spPr>
-        <p:style>
-          <a:lnRef idx="1">
-            <a:schemeClr val="accent1"/>
-          </a:lnRef>
-          <a:fillRef idx="3">
-            <a:schemeClr val="accent1"/>
-          </a:fillRef>
-          <a:effectRef idx="2">
-            <a:schemeClr val="accent1"/>
-          </a:effectRef>
-          <a:fontRef idx="minor">
-            <a:schemeClr val="lt1"/>
-          </a:fontRef>
-        </p:style>
-        <p:txBody>
-          <a:bodyPr rtlCol="0" anchor="ctr"/>
-          <a:lstStyle/>
-          <a:p>
-            <a:pPr algn="ctr"/>
-          </a:p>
-        </p:txBody>
-      </p:sp>
-      <p:sp>
-        <p:nvSpPr>
-          <p:cNvPr id="10" name="TextBox 9"/>
+          <p:cNvPr id="42" name="TextBox 41"/>
           <p:cNvSpPr txBox="1"/>
           <p:nvPr/>
         </p:nvSpPr>
         <p:spPr>
           <a:xfrm>
-            <a:off x="4590288" y="1261872"/>
-            <a:ext cx="3017520" cy="182880"/>
+            <a:off x="566928" y="6236208"/>
+            <a:ext cx="11055096" cy="365760"/>
           </a:xfrm>
           <a:prstGeom prst="rect">
             <a:avLst/>
@@ -12642,452 +12596,6 @@
         </p:spPr>
         <p:txBody>
           <a:bodyPr wrap="square" anchor="t" lIns="0" rIns="0" tIns="0" bIns="0">
-            <a:spAutoFit/>
-          </a:bodyPr>
-          <a:lstStyle/>
-          <a:p>
-            <a:pPr algn="ctr">
-              <a:lnSpc>
-                <a:spcPct val="100000"/>
-              </a:lnSpc>
-              <a:spcBef>
-                <a:spcPts val="0"/>
-              </a:spcBef>
-              <a:spcAft>
-                <a:spcPts val="400"/>
-              </a:spcAft>
-            </a:pPr>
-            <a:r>
-              <a:rPr sz="900" b="0" i="0">
-                <a:solidFill>
-                  <a:srgbClr val="5C6B7A"/>
-                </a:solidFill>
-                <a:latin typeface="Segoe UI"/>
-              </a:rPr>
-              <a:t>«part def»</a:t>
-            </a:r>
-          </a:p>
-        </p:txBody>
-      </p:sp>
-      <p:sp>
-        <p:nvSpPr>
-          <p:cNvPr id="11" name="TextBox 10"/>
-          <p:cNvSpPr txBox="1"/>
-          <p:nvPr/>
-        </p:nvSpPr>
-        <p:spPr>
-          <a:xfrm>
-            <a:off x="4590288" y="1435608"/>
-            <a:ext cx="3017520" cy="347472"/>
-          </a:xfrm>
-          <a:prstGeom prst="rect">
-            <a:avLst/>
-          </a:prstGeom>
-          <a:noFill/>
-        </p:spPr>
-        <p:txBody>
-          <a:bodyPr wrap="square" anchor="t" lIns="0" rIns="0" tIns="0" bIns="0">
-            <a:spAutoFit/>
-          </a:bodyPr>
-          <a:lstStyle/>
-          <a:p>
-            <a:pPr algn="ctr">
-              <a:lnSpc>
-                <a:spcPct val="100000"/>
-              </a:lnSpc>
-              <a:spcBef>
-                <a:spcPts val="0"/>
-              </a:spcBef>
-              <a:spcAft>
-                <a:spcPts val="400"/>
-              </a:spcAft>
-            </a:pPr>
-            <a:r>
-              <a:rPr sz="1300" b="1" i="0">
-                <a:solidFill>
-                  <a:srgbClr val="0F2540"/>
-                </a:solidFill>
-                <a:latin typeface="Segoe UI"/>
-              </a:rPr>
-              <a:t>AerialObservationSystem</a:t>
-            </a:r>
-          </a:p>
-        </p:txBody>
-      </p:sp>
-      <p:sp>
-        <p:nvSpPr>
-          <p:cNvPr id="12" name="Rectangle 11"/>
-          <p:cNvSpPr/>
-          <p:nvPr/>
-        </p:nvSpPr>
-        <p:spPr>
-          <a:xfrm>
-            <a:off x="6099048" y="1828800"/>
-            <a:ext cx="19050" cy="182880"/>
-          </a:xfrm>
-          <a:prstGeom prst="rect">
-            <a:avLst/>
-          </a:prstGeom>
-          <a:solidFill>
-            <a:srgbClr val="2E86AB"/>
-          </a:solidFill>
-          <a:ln>
-            <a:noFill/>
-          </a:ln>
-          <a:effectLst/>
-        </p:spPr>
-        <p:style>
-          <a:lnRef idx="1">
-            <a:schemeClr val="accent1"/>
-          </a:lnRef>
-          <a:fillRef idx="3">
-            <a:schemeClr val="accent1"/>
-          </a:fillRef>
-          <a:effectRef idx="2">
-            <a:schemeClr val="accent1"/>
-          </a:effectRef>
-          <a:fontRef idx="minor">
-            <a:schemeClr val="lt1"/>
-          </a:fontRef>
-        </p:style>
-        <p:txBody>
-          <a:bodyPr rtlCol="0" anchor="ctr"/>
-          <a:lstStyle/>
-          <a:p>
-            <a:pPr algn="ctr"/>
-          </a:p>
-        </p:txBody>
-      </p:sp>
-      <p:sp>
-        <p:nvSpPr>
-          <p:cNvPr id="13" name="Rectangle 12"/>
-          <p:cNvSpPr/>
-          <p:nvPr/>
-        </p:nvSpPr>
-        <p:spPr>
-          <a:xfrm>
-            <a:off x="3241548" y="2011680"/>
-            <a:ext cx="5715000" cy="19050"/>
-          </a:xfrm>
-          <a:prstGeom prst="rect">
-            <a:avLst/>
-          </a:prstGeom>
-          <a:solidFill>
-            <a:srgbClr val="2E86AB"/>
-          </a:solidFill>
-          <a:ln>
-            <a:noFill/>
-          </a:ln>
-          <a:effectLst/>
-        </p:spPr>
-        <p:style>
-          <a:lnRef idx="1">
-            <a:schemeClr val="accent1"/>
-          </a:lnRef>
-          <a:fillRef idx="3">
-            <a:schemeClr val="accent1"/>
-          </a:fillRef>
-          <a:effectRef idx="2">
-            <a:schemeClr val="accent1"/>
-          </a:effectRef>
-          <a:fontRef idx="minor">
-            <a:schemeClr val="lt1"/>
-          </a:fontRef>
-        </p:style>
-        <p:txBody>
-          <a:bodyPr rtlCol="0" anchor="ctr"/>
-          <a:lstStyle/>
-          <a:p>
-            <a:pPr algn="ctr"/>
-          </a:p>
-        </p:txBody>
-      </p:sp>
-      <p:sp>
-        <p:nvSpPr>
-          <p:cNvPr id="14" name="Rectangle 13"/>
-          <p:cNvSpPr/>
-          <p:nvPr/>
-        </p:nvSpPr>
-        <p:spPr>
-          <a:xfrm>
-            <a:off x="3241548" y="2011680"/>
-            <a:ext cx="19050" cy="128016"/>
-          </a:xfrm>
-          <a:prstGeom prst="rect">
-            <a:avLst/>
-          </a:prstGeom>
-          <a:solidFill>
-            <a:srgbClr val="2E86AB"/>
-          </a:solidFill>
-          <a:ln>
-            <a:noFill/>
-          </a:ln>
-          <a:effectLst/>
-        </p:spPr>
-        <p:style>
-          <a:lnRef idx="1">
-            <a:schemeClr val="accent1"/>
-          </a:lnRef>
-          <a:fillRef idx="3">
-            <a:schemeClr val="accent1"/>
-          </a:fillRef>
-          <a:effectRef idx="2">
-            <a:schemeClr val="accent1"/>
-          </a:effectRef>
-          <a:fontRef idx="minor">
-            <a:schemeClr val="lt1"/>
-          </a:fontRef>
-        </p:style>
-        <p:txBody>
-          <a:bodyPr rtlCol="0" anchor="ctr"/>
-          <a:lstStyle/>
-          <a:p>
-            <a:pPr algn="ctr"/>
-          </a:p>
-        </p:txBody>
-      </p:sp>
-      <p:sp>
-        <p:nvSpPr>
-          <p:cNvPr id="15" name="Rectangle 14"/>
-          <p:cNvSpPr/>
-          <p:nvPr/>
-        </p:nvSpPr>
-        <p:spPr>
-          <a:xfrm>
-            <a:off x="8956548" y="2011680"/>
-            <a:ext cx="19050" cy="128016"/>
-          </a:xfrm>
-          <a:prstGeom prst="rect">
-            <a:avLst/>
-          </a:prstGeom>
-          <a:solidFill>
-            <a:srgbClr val="2E86AB"/>
-          </a:solidFill>
-          <a:ln>
-            <a:noFill/>
-          </a:ln>
-          <a:effectLst/>
-        </p:spPr>
-        <p:style>
-          <a:lnRef idx="1">
-            <a:schemeClr val="accent1"/>
-          </a:lnRef>
-          <a:fillRef idx="3">
-            <a:schemeClr val="accent1"/>
-          </a:fillRef>
-          <a:effectRef idx="2">
-            <a:schemeClr val="accent1"/>
-          </a:effectRef>
-          <a:fontRef idx="minor">
-            <a:schemeClr val="lt1"/>
-          </a:fontRef>
-        </p:style>
-        <p:txBody>
-          <a:bodyPr rtlCol="0" anchor="ctr"/>
-          <a:lstStyle/>
-          <a:p>
-            <a:pPr algn="ctr"/>
-          </a:p>
-        </p:txBody>
-      </p:sp>
-      <p:sp>
-        <p:nvSpPr>
-          <p:cNvPr id="16" name="Rectangle 15"/>
-          <p:cNvSpPr/>
-          <p:nvPr/>
-        </p:nvSpPr>
-        <p:spPr>
-          <a:xfrm>
-            <a:off x="566928" y="2139696"/>
-            <a:ext cx="5349240" cy="4023360"/>
-          </a:xfrm>
-          <a:prstGeom prst="rect">
-            <a:avLst/>
-          </a:prstGeom>
-          <a:solidFill>
-            <a:srgbClr val="FFFFFF"/>
-          </a:solidFill>
-          <a:ln w="19050">
-            <a:solidFill>
-              <a:srgbClr val="2E86AB"/>
-            </a:solidFill>
-          </a:ln>
-          <a:effectLst/>
-        </p:spPr>
-        <p:style>
-          <a:lnRef idx="1">
-            <a:schemeClr val="accent1"/>
-          </a:lnRef>
-          <a:fillRef idx="3">
-            <a:schemeClr val="accent1"/>
-          </a:fillRef>
-          <a:effectRef idx="2">
-            <a:schemeClr val="accent1"/>
-          </a:effectRef>
-          <a:fontRef idx="minor">
-            <a:schemeClr val="lt1"/>
-          </a:fontRef>
-        </p:style>
-        <p:txBody>
-          <a:bodyPr rtlCol="0" anchor="ctr"/>
-          <a:lstStyle/>
-          <a:p>
-            <a:pPr algn="ctr"/>
-          </a:p>
-        </p:txBody>
-      </p:sp>
-      <p:sp>
-        <p:nvSpPr>
-          <p:cNvPr id="17" name="Rectangle 16"/>
-          <p:cNvSpPr/>
-          <p:nvPr/>
-        </p:nvSpPr>
-        <p:spPr>
-          <a:xfrm>
-            <a:off x="566928" y="2139696"/>
-            <a:ext cx="5349240" cy="548640"/>
-          </a:xfrm>
-          <a:prstGeom prst="rect">
-            <a:avLst/>
-          </a:prstGeom>
-          <a:solidFill>
-            <a:srgbClr val="1F3A5F"/>
-          </a:solidFill>
-          <a:ln>
-            <a:noFill/>
-          </a:ln>
-          <a:effectLst/>
-        </p:spPr>
-        <p:style>
-          <a:lnRef idx="1">
-            <a:schemeClr val="accent1"/>
-          </a:lnRef>
-          <a:fillRef idx="3">
-            <a:schemeClr val="accent1"/>
-          </a:fillRef>
-          <a:effectRef idx="2">
-            <a:schemeClr val="accent1"/>
-          </a:effectRef>
-          <a:fontRef idx="minor">
-            <a:schemeClr val="lt1"/>
-          </a:fontRef>
-        </p:style>
-        <p:txBody>
-          <a:bodyPr rtlCol="0" anchor="ctr"/>
-          <a:lstStyle/>
-          <a:p>
-            <a:pPr algn="ctr"/>
-          </a:p>
-        </p:txBody>
-      </p:sp>
-      <p:sp>
-        <p:nvSpPr>
-          <p:cNvPr id="18" name="TextBox 17"/>
-          <p:cNvSpPr txBox="1"/>
-          <p:nvPr/>
-        </p:nvSpPr>
-        <p:spPr>
-          <a:xfrm>
-            <a:off x="566928" y="2185416"/>
-            <a:ext cx="5349240" cy="182880"/>
-          </a:xfrm>
-          <a:prstGeom prst="rect">
-            <a:avLst/>
-          </a:prstGeom>
-          <a:noFill/>
-        </p:spPr>
-        <p:txBody>
-          <a:bodyPr wrap="square" anchor="t" lIns="0" rIns="0" tIns="0" bIns="0">
-            <a:spAutoFit/>
-          </a:bodyPr>
-          <a:lstStyle/>
-          <a:p>
-            <a:pPr algn="ctr">
-              <a:lnSpc>
-                <a:spcPct val="100000"/>
-              </a:lnSpc>
-              <a:spcBef>
-                <a:spcPts val="0"/>
-              </a:spcBef>
-              <a:spcAft>
-                <a:spcPts val="400"/>
-              </a:spcAft>
-            </a:pPr>
-            <a:r>
-              <a:rPr sz="900" b="0" i="0">
-                <a:solidFill>
-                  <a:srgbClr val="BBD0E0"/>
-                </a:solidFill>
-                <a:latin typeface="Segoe UI"/>
-              </a:rPr>
-              <a:t>«part def»</a:t>
-            </a:r>
-          </a:p>
-        </p:txBody>
-      </p:sp>
-      <p:sp>
-        <p:nvSpPr>
-          <p:cNvPr id="19" name="TextBox 18"/>
-          <p:cNvSpPr txBox="1"/>
-          <p:nvPr/>
-        </p:nvSpPr>
-        <p:spPr>
-          <a:xfrm>
-            <a:off x="566928" y="2359152"/>
-            <a:ext cx="5349240" cy="274320"/>
-          </a:xfrm>
-          <a:prstGeom prst="rect">
-            <a:avLst/>
-          </a:prstGeom>
-          <a:noFill/>
-        </p:spPr>
-        <p:txBody>
-          <a:bodyPr wrap="square" anchor="t" lIns="0" rIns="0" tIns="0" bIns="0">
-            <a:spAutoFit/>
-          </a:bodyPr>
-          <a:lstStyle/>
-          <a:p>
-            <a:pPr algn="ctr">
-              <a:lnSpc>
-                <a:spcPct val="100000"/>
-              </a:lnSpc>
-              <a:spcBef>
-                <a:spcPts val="0"/>
-              </a:spcBef>
-              <a:spcAft>
-                <a:spcPts val="400"/>
-              </a:spcAft>
-            </a:pPr>
-            <a:r>
-              <a:rPr sz="1400" b="1" i="0">
-                <a:solidFill>
-                  <a:srgbClr val="FFFFFF"/>
-                </a:solidFill>
-                <a:latin typeface="Segoe UI"/>
-              </a:rPr>
-              <a:t>Drone</a:t>
-            </a:r>
-          </a:p>
-        </p:txBody>
-      </p:sp>
-      <p:sp>
-        <p:nvSpPr>
-          <p:cNvPr id="20" name="TextBox 19"/>
-          <p:cNvSpPr txBox="1"/>
-          <p:nvPr/>
-        </p:nvSpPr>
-        <p:spPr>
-          <a:xfrm>
-            <a:off x="749808" y="2798064"/>
-            <a:ext cx="4983480" cy="300920"/>
-          </a:xfrm>
-          <a:prstGeom prst="rect">
-            <a:avLst/>
-          </a:prstGeom>
-          <a:noFill/>
-        </p:spPr>
-        <p:txBody>
-          <a:bodyPr wrap="square" anchor="ctr" lIns="0" rIns="0" tIns="0" bIns="0">
             <a:spAutoFit/>
           </a:bodyPr>
           <a:lstStyle/>
@@ -13104,1205 +12612,77 @@
               </a:spcAft>
             </a:pPr>
             <a:r>
-              <a:rPr sz="1150" b="0" i="0">
+              <a:rPr sz="1000" b="0" i="0">
                 <a:solidFill>
                   <a:srgbClr val="5C6B7A"/>
                 </a:solidFill>
                 <a:latin typeface="Segoe UI"/>
               </a:rPr>
-              <a:t>platform  :  </a:t>
-            </a:r>
-            <a:r>
-              <a:rPr sz="1150" b="1" i="0">
-                <a:solidFill>
-                  <a:srgbClr val="0F2540"/>
-                </a:solidFill>
-                <a:latin typeface="Segoe UI"/>
-              </a:rPr>
-              <a:t>Airframe</a:t>
-            </a:r>
-          </a:p>
-        </p:txBody>
-      </p:sp>
-      <p:sp>
-        <p:nvSpPr>
-          <p:cNvPr id="21" name="TextBox 20"/>
-          <p:cNvSpPr txBox="1"/>
-          <p:nvPr/>
-        </p:nvSpPr>
-        <p:spPr>
-          <a:xfrm>
-            <a:off x="749808" y="3098984"/>
-            <a:ext cx="4983480" cy="300920"/>
-          </a:xfrm>
-          <a:prstGeom prst="rect">
-            <a:avLst/>
-          </a:prstGeom>
-          <a:noFill/>
-        </p:spPr>
-        <p:txBody>
-          <a:bodyPr wrap="square" anchor="ctr" lIns="0" rIns="0" tIns="0" bIns="0">
-            <a:spAutoFit/>
-          </a:bodyPr>
-          <a:lstStyle/>
-          <a:p>
-            <a:pPr algn="l">
-              <a:lnSpc>
-                <a:spcPct val="100000"/>
-              </a:lnSpc>
-              <a:spcBef>
-                <a:spcPts val="0"/>
-              </a:spcBef>
-              <a:spcAft>
-                <a:spcPts val="400"/>
-              </a:spcAft>
-            </a:pPr>
-            <a:r>
-              <a:rPr sz="1150" b="0" i="0">
+              <a:t>Block-definition (composition) view — the SysML v2 analog of a BDD: each </a:t>
+            </a:r>
+            <a:r>
+              <a:rPr sz="1000" b="1" i="0">
                 <a:solidFill>
                   <a:srgbClr val="5C6B7A"/>
                 </a:solidFill>
                 <a:latin typeface="Segoe UI"/>
               </a:rPr>
-              <a:t>battery  :  </a:t>
-            </a:r>
-            <a:r>
-              <a:rPr sz="1150" b="1" i="0">
-                <a:solidFill>
-                  <a:srgbClr val="0F2540"/>
-                </a:solidFill>
-                <a:latin typeface="Segoe UI"/>
-              </a:rPr>
-              <a:t>Battery</a:t>
-            </a:r>
-          </a:p>
-        </p:txBody>
-      </p:sp>
-      <p:sp>
-        <p:nvSpPr>
-          <p:cNvPr id="22" name="TextBox 21"/>
-          <p:cNvSpPr txBox="1"/>
-          <p:nvPr/>
-        </p:nvSpPr>
-        <p:spPr>
-          <a:xfrm>
-            <a:off x="749808" y="3399904"/>
-            <a:ext cx="4983480" cy="300920"/>
-          </a:xfrm>
-          <a:prstGeom prst="rect">
-            <a:avLst/>
-          </a:prstGeom>
-          <a:noFill/>
-        </p:spPr>
-        <p:txBody>
-          <a:bodyPr wrap="square" anchor="ctr" lIns="0" rIns="0" tIns="0" bIns="0">
-            <a:spAutoFit/>
-          </a:bodyPr>
-          <a:lstStyle/>
-          <a:p>
-            <a:pPr algn="l">
-              <a:lnSpc>
-                <a:spcPct val="100000"/>
-              </a:lnSpc>
-              <a:spcBef>
-                <a:spcPts val="0"/>
-              </a:spcBef>
-              <a:spcAft>
-                <a:spcPts val="400"/>
-              </a:spcAft>
-            </a:pPr>
-            <a:r>
-              <a:rPr sz="1150" b="0" i="0">
+              <a:t>part def</a:t>
+            </a:r>
+            <a:r>
+              <a:rPr sz="1000" b="0" i="0">
                 <a:solidFill>
                   <a:srgbClr val="5C6B7A"/>
                 </a:solidFill>
                 <a:latin typeface="Segoe UI"/>
               </a:rPr>
-              <a:t>antiSpark  :  </a:t>
-            </a:r>
-            <a:r>
-              <a:rPr sz="1150" b="1" i="0">
-                <a:solidFill>
-                  <a:srgbClr val="0F2540"/>
-                </a:solidFill>
-                <a:latin typeface="Segoe UI"/>
-              </a:rPr>
-              <a:t>AntiSparkFilter</a:t>
-            </a:r>
-          </a:p>
-        </p:txBody>
-      </p:sp>
-      <p:sp>
-        <p:nvSpPr>
-          <p:cNvPr id="23" name="TextBox 22"/>
-          <p:cNvSpPr txBox="1"/>
-          <p:nvPr/>
-        </p:nvSpPr>
-        <p:spPr>
-          <a:xfrm>
-            <a:off x="749808" y="3700824"/>
-            <a:ext cx="4983480" cy="300920"/>
-          </a:xfrm>
-          <a:prstGeom prst="rect">
-            <a:avLst/>
-          </a:prstGeom>
-          <a:noFill/>
-        </p:spPr>
-        <p:txBody>
-          <a:bodyPr wrap="square" anchor="ctr" lIns="0" rIns="0" tIns="0" bIns="0">
-            <a:spAutoFit/>
-          </a:bodyPr>
-          <a:lstStyle/>
-          <a:p>
-            <a:pPr algn="l">
-              <a:lnSpc>
-                <a:spcPct val="100000"/>
-              </a:lnSpc>
-              <a:spcBef>
-                <a:spcPts val="0"/>
-              </a:spcBef>
-              <a:spcAft>
-                <a:spcPts val="400"/>
-              </a:spcAft>
-            </a:pPr>
-            <a:r>
-              <a:rPr sz="1150" b="0" i="0">
+              <a:t> and the typed </a:t>
+            </a:r>
+            <a:r>
+              <a:rPr sz="1000" b="1" i="0">
                 <a:solidFill>
                   <a:srgbClr val="5C6B7A"/>
                 </a:solidFill>
                 <a:latin typeface="Segoe UI"/>
               </a:rPr>
-              <a:t>camera  :  </a:t>
-            </a:r>
-            <a:r>
-              <a:rPr sz="1150" b="1" i="0">
-                <a:solidFill>
-                  <a:srgbClr val="0F2540"/>
-                </a:solidFill>
-                <a:latin typeface="Segoe UI"/>
-              </a:rPr>
-              <a:t>IRCamera</a:t>
-            </a:r>
-          </a:p>
-        </p:txBody>
-      </p:sp>
-      <p:sp>
-        <p:nvSpPr>
-          <p:cNvPr id="24" name="TextBox 23"/>
-          <p:cNvSpPr txBox="1"/>
-          <p:nvPr/>
-        </p:nvSpPr>
-        <p:spPr>
-          <a:xfrm>
-            <a:off x="749808" y="4001744"/>
-            <a:ext cx="4983480" cy="300920"/>
-          </a:xfrm>
-          <a:prstGeom prst="rect">
-            <a:avLst/>
-          </a:prstGeom>
-          <a:noFill/>
-        </p:spPr>
-        <p:txBody>
-          <a:bodyPr wrap="square" anchor="ctr" lIns="0" rIns="0" tIns="0" bIns="0">
-            <a:spAutoFit/>
-          </a:bodyPr>
-          <a:lstStyle/>
-          <a:p>
-            <a:pPr algn="l">
-              <a:lnSpc>
-                <a:spcPct val="100000"/>
-              </a:lnSpc>
-              <a:spcBef>
-                <a:spcPts val="0"/>
-              </a:spcBef>
-              <a:spcAft>
-                <a:spcPts val="400"/>
-              </a:spcAft>
-            </a:pPr>
-            <a:r>
-              <a:rPr sz="1150" b="0" i="0">
+              <a:t>part</a:t>
+            </a:r>
+            <a:r>
+              <a:rPr sz="1000" b="0" i="0">
                 <a:solidFill>
                   <a:srgbClr val="5C6B7A"/>
                 </a:solidFill>
                 <a:latin typeface="Segoe UI"/>
               </a:rPr>
-              <a:t>fpvCam  :  </a:t>
-            </a:r>
-            <a:r>
-              <a:rPr sz="1150" b="1" i="0">
-                <a:solidFill>
-                  <a:srgbClr val="0F2540"/>
-                </a:solidFill>
-                <a:latin typeface="Segoe UI"/>
-              </a:rPr>
-              <a:t>FpvCamera</a:t>
-            </a:r>
-          </a:p>
-        </p:txBody>
-      </p:sp>
-      <p:sp>
-        <p:nvSpPr>
-          <p:cNvPr id="25" name="TextBox 24"/>
-          <p:cNvSpPr txBox="1"/>
-          <p:nvPr/>
-        </p:nvSpPr>
-        <p:spPr>
-          <a:xfrm>
-            <a:off x="749808" y="4302664"/>
-            <a:ext cx="4983480" cy="300920"/>
-          </a:xfrm>
-          <a:prstGeom prst="rect">
-            <a:avLst/>
-          </a:prstGeom>
-          <a:noFill/>
-        </p:spPr>
-        <p:txBody>
-          <a:bodyPr wrap="square" anchor="ctr" lIns="0" rIns="0" tIns="0" bIns="0">
-            <a:spAutoFit/>
-          </a:bodyPr>
-          <a:lstStyle/>
-          <a:p>
-            <a:pPr algn="l">
-              <a:lnSpc>
-                <a:spcPct val="100000"/>
-              </a:lnSpc>
-              <a:spcBef>
-                <a:spcPts val="0"/>
-              </a:spcBef>
-              <a:spcAft>
-                <a:spcPts val="400"/>
-              </a:spcAft>
-            </a:pPr>
-            <a:r>
-              <a:rPr sz="1150" b="0" i="0">
-                <a:solidFill>
-                  <a:srgbClr val="5C6B7A"/>
-                </a:solidFill>
-                <a:latin typeface="Segoe UI"/>
-              </a:rPr>
-              <a:t>gps  :  </a:t>
-            </a:r>
-            <a:r>
-              <a:rPr sz="1150" b="1" i="0">
-                <a:solidFill>
-                  <a:srgbClr val="0F2540"/>
-                </a:solidFill>
-                <a:latin typeface="Segoe UI"/>
-              </a:rPr>
-              <a:t>GpsModule</a:t>
-            </a:r>
-          </a:p>
-        </p:txBody>
-      </p:sp>
-      <p:sp>
-        <p:nvSpPr>
-          <p:cNvPr id="26" name="TextBox 25"/>
-          <p:cNvSpPr txBox="1"/>
-          <p:nvPr/>
-        </p:nvSpPr>
-        <p:spPr>
-          <a:xfrm>
-            <a:off x="749808" y="4603584"/>
-            <a:ext cx="4983480" cy="300920"/>
-          </a:xfrm>
-          <a:prstGeom prst="rect">
-            <a:avLst/>
-          </a:prstGeom>
-          <a:noFill/>
-        </p:spPr>
-        <p:txBody>
-          <a:bodyPr wrap="square" anchor="ctr" lIns="0" rIns="0" tIns="0" bIns="0">
-            <a:spAutoFit/>
-          </a:bodyPr>
-          <a:lstStyle/>
-          <a:p>
-            <a:pPr algn="l">
-              <a:lnSpc>
-                <a:spcPct val="100000"/>
-              </a:lnSpc>
-              <a:spcBef>
-                <a:spcPts val="0"/>
-              </a:spcBef>
-              <a:spcAft>
-                <a:spcPts val="400"/>
-              </a:spcAft>
-            </a:pPr>
-            <a:r>
-              <a:rPr sz="1150" b="0" i="0">
-                <a:solidFill>
-                  <a:srgbClr val="5C6B7A"/>
-                </a:solidFill>
-                <a:latin typeface="Segoe UI"/>
-              </a:rPr>
-              <a:t>sbc  :  </a:t>
-            </a:r>
-            <a:r>
-              <a:rPr sz="1150" b="1" i="0">
-                <a:solidFill>
-                  <a:srgbClr val="0F2540"/>
-                </a:solidFill>
-                <a:latin typeface="Segoe UI"/>
-              </a:rPr>
-              <a:t>SBCPayload</a:t>
-            </a:r>
-          </a:p>
-        </p:txBody>
-      </p:sp>
-      <p:sp>
-        <p:nvSpPr>
-          <p:cNvPr id="27" name="TextBox 26"/>
-          <p:cNvSpPr txBox="1"/>
-          <p:nvPr/>
-        </p:nvSpPr>
-        <p:spPr>
-          <a:xfrm>
-            <a:off x="749808" y="4904504"/>
-            <a:ext cx="4983480" cy="300920"/>
-          </a:xfrm>
-          <a:prstGeom prst="rect">
-            <a:avLst/>
-          </a:prstGeom>
-          <a:noFill/>
-        </p:spPr>
-        <p:txBody>
-          <a:bodyPr wrap="square" anchor="ctr" lIns="0" rIns="0" tIns="0" bIns="0">
-            <a:spAutoFit/>
-          </a:bodyPr>
-          <a:lstStyle/>
-          <a:p>
-            <a:pPr algn="l">
-              <a:lnSpc>
-                <a:spcPct val="100000"/>
-              </a:lnSpc>
-              <a:spcBef>
-                <a:spcPts val="0"/>
-              </a:spcBef>
-              <a:spcAft>
-                <a:spcPts val="400"/>
-              </a:spcAft>
-            </a:pPr>
-            <a:r>
-              <a:rPr sz="1150" b="0" i="0">
-                <a:solidFill>
-                  <a:srgbClr val="5C6B7A"/>
-                </a:solidFill>
-                <a:latin typeface="Segoe UI"/>
-              </a:rPr>
-              <a:t>rx  :  </a:t>
-            </a:r>
-            <a:r>
-              <a:rPr sz="1150" b="1" i="0">
-                <a:solidFill>
-                  <a:srgbClr val="0F2540"/>
-                </a:solidFill>
-                <a:latin typeface="Segoe UI"/>
-              </a:rPr>
-              <a:t>RadioReceiver</a:t>
-            </a:r>
-          </a:p>
-        </p:txBody>
-      </p:sp>
-      <p:sp>
-        <p:nvSpPr>
-          <p:cNvPr id="28" name="TextBox 27"/>
-          <p:cNvSpPr txBox="1"/>
-          <p:nvPr/>
-        </p:nvSpPr>
-        <p:spPr>
-          <a:xfrm>
-            <a:off x="749808" y="5205424"/>
-            <a:ext cx="4983480" cy="300920"/>
-          </a:xfrm>
-          <a:prstGeom prst="rect">
-            <a:avLst/>
-          </a:prstGeom>
-          <a:noFill/>
-        </p:spPr>
-        <p:txBody>
-          <a:bodyPr wrap="square" anchor="ctr" lIns="0" rIns="0" tIns="0" bIns="0">
-            <a:spAutoFit/>
-          </a:bodyPr>
-          <a:lstStyle/>
-          <a:p>
-            <a:pPr algn="l">
-              <a:lnSpc>
-                <a:spcPct val="100000"/>
-              </a:lnSpc>
-              <a:spcBef>
-                <a:spcPts val="0"/>
-              </a:spcBef>
-              <a:spcAft>
-                <a:spcPts val="400"/>
-              </a:spcAft>
-            </a:pPr>
-            <a:r>
-              <a:rPr sz="1150" b="0" i="0">
-                <a:solidFill>
-                  <a:srgbClr val="5C6B7A"/>
-                </a:solidFill>
-                <a:latin typeface="Segoe UI"/>
-              </a:rPr>
-              <a:t>vtx  :  </a:t>
-            </a:r>
-            <a:r>
-              <a:rPr sz="1150" b="1" i="0">
-                <a:solidFill>
-                  <a:srgbClr val="0F2540"/>
-                </a:solidFill>
-                <a:latin typeface="Segoe UI"/>
-              </a:rPr>
-              <a:t>Vtx</a:t>
-            </a:r>
-          </a:p>
-        </p:txBody>
-      </p:sp>
-      <p:sp>
-        <p:nvSpPr>
-          <p:cNvPr id="29" name="TextBox 28"/>
-          <p:cNvSpPr txBox="1"/>
-          <p:nvPr/>
-        </p:nvSpPr>
-        <p:spPr>
-          <a:xfrm>
-            <a:off x="749808" y="5506344"/>
-            <a:ext cx="4983480" cy="300920"/>
-          </a:xfrm>
-          <a:prstGeom prst="rect">
-            <a:avLst/>
-          </a:prstGeom>
-          <a:noFill/>
-        </p:spPr>
-        <p:txBody>
-          <a:bodyPr wrap="square" anchor="ctr" lIns="0" rIns="0" tIns="0" bIns="0">
-            <a:spAutoFit/>
-          </a:bodyPr>
-          <a:lstStyle/>
-          <a:p>
-            <a:pPr algn="l">
-              <a:lnSpc>
-                <a:spcPct val="100000"/>
-              </a:lnSpc>
-              <a:spcBef>
-                <a:spcPts val="0"/>
-              </a:spcBef>
-              <a:spcAft>
-                <a:spcPts val="400"/>
-              </a:spcAft>
-            </a:pPr>
-            <a:r>
-              <a:rPr sz="1150" b="0" i="0">
-                <a:solidFill>
-                  <a:srgbClr val="5C6B7A"/>
-                </a:solidFill>
-                <a:latin typeface="Segoe UI"/>
-              </a:rPr>
-              <a:t>ubec  :  </a:t>
-            </a:r>
-            <a:r>
-              <a:rPr sz="1150" b="1" i="0">
-                <a:solidFill>
-                  <a:srgbClr val="0F2540"/>
-                </a:solidFill>
-                <a:latin typeface="Segoe UI"/>
-              </a:rPr>
-              <a:t>Ubec</a:t>
-            </a:r>
-          </a:p>
-        </p:txBody>
-      </p:sp>
-      <p:sp>
-        <p:nvSpPr>
-          <p:cNvPr id="30" name="TextBox 29"/>
-          <p:cNvSpPr txBox="1"/>
-          <p:nvPr/>
-        </p:nvSpPr>
-        <p:spPr>
-          <a:xfrm>
-            <a:off x="749808" y="5807264"/>
-            <a:ext cx="4983480" cy="300920"/>
-          </a:xfrm>
-          <a:prstGeom prst="rect">
-            <a:avLst/>
-          </a:prstGeom>
-          <a:noFill/>
-        </p:spPr>
-        <p:txBody>
-          <a:bodyPr wrap="square" anchor="ctr" lIns="0" rIns="0" tIns="0" bIns="0">
-            <a:spAutoFit/>
-          </a:bodyPr>
-          <a:lstStyle/>
-          <a:p>
-            <a:pPr algn="l">
-              <a:lnSpc>
-                <a:spcPct val="100000"/>
-              </a:lnSpc>
-              <a:spcBef>
-                <a:spcPts val="0"/>
-              </a:spcBef>
-              <a:spcAft>
-                <a:spcPts val="400"/>
-              </a:spcAft>
-            </a:pPr>
-            <a:r>
-              <a:rPr sz="1150" b="0" i="0">
-                <a:solidFill>
-                  <a:srgbClr val="5C6B7A"/>
-                </a:solidFill>
-                <a:latin typeface="Segoe UI"/>
-              </a:rPr>
-              <a:t>vtxAntenna, rxAntennaA/B  :  </a:t>
-            </a:r>
-            <a:r>
-              <a:rPr sz="1150" b="1" i="0">
-                <a:solidFill>
-                  <a:srgbClr val="0F2540"/>
-                </a:solidFill>
-                <a:latin typeface="Segoe UI"/>
-              </a:rPr>
-              <a:t>Antenna [3]</a:t>
-            </a:r>
-          </a:p>
-        </p:txBody>
-      </p:sp>
-      <p:sp>
-        <p:nvSpPr>
-          <p:cNvPr id="31" name="Rectangle 30"/>
-          <p:cNvSpPr/>
-          <p:nvPr/>
-        </p:nvSpPr>
-        <p:spPr>
-          <a:xfrm>
-            <a:off x="6281928" y="2139696"/>
-            <a:ext cx="5349240" cy="4023360"/>
-          </a:xfrm>
-          <a:prstGeom prst="rect">
-            <a:avLst/>
-          </a:prstGeom>
-          <a:solidFill>
-            <a:srgbClr val="FFFFFF"/>
-          </a:solidFill>
-          <a:ln w="19050">
-            <a:solidFill>
-              <a:srgbClr val="2E86AB"/>
-            </a:solidFill>
-          </a:ln>
-          <a:effectLst/>
-        </p:spPr>
-        <p:style>
-          <a:lnRef idx="1">
-            <a:schemeClr val="accent1"/>
-          </a:lnRef>
-          <a:fillRef idx="3">
-            <a:schemeClr val="accent1"/>
-          </a:fillRef>
-          <a:effectRef idx="2">
-            <a:schemeClr val="accent1"/>
-          </a:effectRef>
-          <a:fontRef idx="minor">
-            <a:schemeClr val="lt1"/>
-          </a:fontRef>
-        </p:style>
-        <p:txBody>
-          <a:bodyPr rtlCol="0" anchor="ctr"/>
-          <a:lstStyle/>
-          <a:p>
-            <a:pPr algn="ctr"/>
-          </a:p>
-        </p:txBody>
-      </p:sp>
-      <p:sp>
-        <p:nvSpPr>
-          <p:cNvPr id="32" name="Rectangle 31"/>
-          <p:cNvSpPr/>
-          <p:nvPr/>
-        </p:nvSpPr>
-        <p:spPr>
-          <a:xfrm>
-            <a:off x="6281928" y="2139696"/>
-            <a:ext cx="5349240" cy="548640"/>
-          </a:xfrm>
-          <a:prstGeom prst="rect">
-            <a:avLst/>
-          </a:prstGeom>
-          <a:solidFill>
-            <a:srgbClr val="1F3A5F"/>
-          </a:solidFill>
-          <a:ln>
-            <a:noFill/>
-          </a:ln>
-          <a:effectLst/>
-        </p:spPr>
-        <p:style>
-          <a:lnRef idx="1">
-            <a:schemeClr val="accent1"/>
-          </a:lnRef>
-          <a:fillRef idx="3">
-            <a:schemeClr val="accent1"/>
-          </a:fillRef>
-          <a:effectRef idx="2">
-            <a:schemeClr val="accent1"/>
-          </a:effectRef>
-          <a:fontRef idx="minor">
-            <a:schemeClr val="lt1"/>
-          </a:fontRef>
-        </p:style>
-        <p:txBody>
-          <a:bodyPr rtlCol="0" anchor="ctr"/>
-          <a:lstStyle/>
-          <a:p>
-            <a:pPr algn="ctr"/>
-          </a:p>
-        </p:txBody>
-      </p:sp>
-      <p:sp>
-        <p:nvSpPr>
-          <p:cNvPr id="33" name="TextBox 32"/>
-          <p:cNvSpPr txBox="1"/>
-          <p:nvPr/>
-        </p:nvSpPr>
-        <p:spPr>
-          <a:xfrm>
-            <a:off x="6281928" y="2185416"/>
-            <a:ext cx="5349240" cy="182880"/>
-          </a:xfrm>
-          <a:prstGeom prst="rect">
-            <a:avLst/>
-          </a:prstGeom>
-          <a:noFill/>
-        </p:spPr>
-        <p:txBody>
-          <a:bodyPr wrap="square" anchor="t" lIns="0" rIns="0" tIns="0" bIns="0">
-            <a:spAutoFit/>
-          </a:bodyPr>
-          <a:lstStyle/>
-          <a:p>
-            <a:pPr algn="ctr">
-              <a:lnSpc>
-                <a:spcPct val="100000"/>
-              </a:lnSpc>
-              <a:spcBef>
-                <a:spcPts val="0"/>
-              </a:spcBef>
-              <a:spcAft>
-                <a:spcPts val="400"/>
-              </a:spcAft>
-            </a:pPr>
-            <a:r>
-              <a:rPr sz="900" b="0" i="0">
-                <a:solidFill>
-                  <a:srgbClr val="BBD0E0"/>
-                </a:solidFill>
-                <a:latin typeface="Segoe UI"/>
-              </a:rPr>
-              <a:t>«part def»</a:t>
-            </a:r>
-          </a:p>
-        </p:txBody>
-      </p:sp>
-      <p:sp>
-        <p:nvSpPr>
-          <p:cNvPr id="34" name="TextBox 33"/>
-          <p:cNvSpPr txBox="1"/>
-          <p:nvPr/>
-        </p:nvSpPr>
-        <p:spPr>
-          <a:xfrm>
-            <a:off x="6281928" y="2359152"/>
-            <a:ext cx="5349240" cy="274320"/>
-          </a:xfrm>
-          <a:prstGeom prst="rect">
-            <a:avLst/>
-          </a:prstGeom>
-          <a:noFill/>
-        </p:spPr>
-        <p:txBody>
-          <a:bodyPr wrap="square" anchor="t" lIns="0" rIns="0" tIns="0" bIns="0">
-            <a:spAutoFit/>
-          </a:bodyPr>
-          <a:lstStyle/>
-          <a:p>
-            <a:pPr algn="ctr">
-              <a:lnSpc>
-                <a:spcPct val="100000"/>
-              </a:lnSpc>
-              <a:spcBef>
-                <a:spcPts val="0"/>
-              </a:spcBef>
-              <a:spcAft>
-                <a:spcPts val="400"/>
-              </a:spcAft>
-            </a:pPr>
-            <a:r>
-              <a:rPr sz="1400" b="1" i="0">
-                <a:solidFill>
-                  <a:srgbClr val="FFFFFF"/>
-                </a:solidFill>
-                <a:latin typeface="Segoe UI"/>
-              </a:rPr>
-              <a:t>GCS</a:t>
-            </a:r>
-          </a:p>
-        </p:txBody>
-      </p:sp>
-      <p:sp>
-        <p:nvSpPr>
-          <p:cNvPr id="35" name="TextBox 34"/>
-          <p:cNvSpPr txBox="1"/>
-          <p:nvPr/>
-        </p:nvSpPr>
-        <p:spPr>
-          <a:xfrm>
-            <a:off x="6464808" y="2798064"/>
-            <a:ext cx="4983480" cy="310896"/>
-          </a:xfrm>
-          <a:prstGeom prst="rect">
-            <a:avLst/>
-          </a:prstGeom>
-          <a:noFill/>
-        </p:spPr>
-        <p:txBody>
-          <a:bodyPr wrap="square" anchor="ctr" lIns="0" rIns="0" tIns="0" bIns="0">
-            <a:spAutoFit/>
-          </a:bodyPr>
-          <a:lstStyle/>
-          <a:p>
-            <a:pPr algn="l">
-              <a:lnSpc>
-                <a:spcPct val="100000"/>
-              </a:lnSpc>
-              <a:spcBef>
-                <a:spcPts val="0"/>
-              </a:spcBef>
-              <a:spcAft>
-                <a:spcPts val="400"/>
-              </a:spcAft>
-            </a:pPr>
-            <a:r>
-              <a:rPr sz="1150" b="0" i="0">
-                <a:solidFill>
-                  <a:srgbClr val="5C6B7A"/>
-                </a:solidFill>
-                <a:latin typeface="Segoe UI"/>
-              </a:rPr>
-              <a:t>viewingComputer  :  </a:t>
-            </a:r>
-            <a:r>
-              <a:rPr sz="1150" b="1" i="0">
-                <a:solidFill>
-                  <a:srgbClr val="0F2540"/>
-                </a:solidFill>
-                <a:latin typeface="Segoe UI"/>
-              </a:rPr>
-              <a:t>Laptop</a:t>
-            </a:r>
-          </a:p>
-        </p:txBody>
-      </p:sp>
-      <p:sp>
-        <p:nvSpPr>
-          <p:cNvPr id="36" name="TextBox 35"/>
-          <p:cNvSpPr txBox="1"/>
-          <p:nvPr/>
-        </p:nvSpPr>
-        <p:spPr>
-          <a:xfrm>
-            <a:off x="6464808" y="3108960"/>
-            <a:ext cx="4983480" cy="310896"/>
-          </a:xfrm>
-          <a:prstGeom prst="rect">
-            <a:avLst/>
-          </a:prstGeom>
-          <a:noFill/>
-        </p:spPr>
-        <p:txBody>
-          <a:bodyPr wrap="square" anchor="ctr" lIns="0" rIns="0" tIns="0" bIns="0">
-            <a:spAutoFit/>
-          </a:bodyPr>
-          <a:lstStyle/>
-          <a:p>
-            <a:pPr algn="l">
-              <a:lnSpc>
-                <a:spcPct val="100000"/>
-              </a:lnSpc>
-              <a:spcBef>
-                <a:spcPts val="0"/>
-              </a:spcBef>
-              <a:spcAft>
-                <a:spcPts val="400"/>
-              </a:spcAft>
-            </a:pPr>
-            <a:r>
-              <a:rPr sz="1150" b="0" i="0">
-                <a:solidFill>
-                  <a:srgbClr val="5C6B7A"/>
-                </a:solidFill>
-                <a:latin typeface="Segoe UI"/>
-              </a:rPr>
-              <a:t>videoRx  :  </a:t>
-            </a:r>
-            <a:r>
-              <a:rPr sz="1150" b="1" i="0">
-                <a:solidFill>
-                  <a:srgbClr val="0F2540"/>
-                </a:solidFill>
-                <a:latin typeface="Segoe UI"/>
-              </a:rPr>
-              <a:t>Vrx</a:t>
-            </a:r>
-          </a:p>
-        </p:txBody>
-      </p:sp>
-      <p:sp>
-        <p:nvSpPr>
-          <p:cNvPr id="37" name="TextBox 36"/>
-          <p:cNvSpPr txBox="1"/>
-          <p:nvPr/>
-        </p:nvSpPr>
-        <p:spPr>
-          <a:xfrm>
-            <a:off x="6464808" y="3419856"/>
-            <a:ext cx="4983480" cy="310896"/>
-          </a:xfrm>
-          <a:prstGeom prst="rect">
-            <a:avLst/>
-          </a:prstGeom>
-          <a:noFill/>
-        </p:spPr>
-        <p:txBody>
-          <a:bodyPr wrap="square" anchor="ctr" lIns="0" rIns="0" tIns="0" bIns="0">
-            <a:spAutoFit/>
-          </a:bodyPr>
-          <a:lstStyle/>
-          <a:p>
-            <a:pPr algn="l">
-              <a:lnSpc>
-                <a:spcPct val="100000"/>
-              </a:lnSpc>
-              <a:spcBef>
-                <a:spcPts val="0"/>
-              </a:spcBef>
-              <a:spcAft>
-                <a:spcPts val="400"/>
-              </a:spcAft>
-            </a:pPr>
-            <a:r>
-              <a:rPr sz="1150" b="0" i="0">
-                <a:solidFill>
-                  <a:srgbClr val="5C6B7A"/>
-                </a:solidFill>
-                <a:latin typeface="Segoe UI"/>
-              </a:rPr>
-              <a:t>capture  :  </a:t>
-            </a:r>
-            <a:r>
-              <a:rPr sz="1150" b="1" i="0">
-                <a:solidFill>
-                  <a:srgbClr val="0F2540"/>
-                </a:solidFill>
-                <a:latin typeface="Segoe UI"/>
-              </a:rPr>
-              <a:t>UsbCap</a:t>
-            </a:r>
-          </a:p>
-        </p:txBody>
-      </p:sp>
-      <p:sp>
-        <p:nvSpPr>
-          <p:cNvPr id="38" name="TextBox 37"/>
-          <p:cNvSpPr txBox="1"/>
-          <p:nvPr/>
-        </p:nvSpPr>
-        <p:spPr>
-          <a:xfrm>
-            <a:off x="6464808" y="3730752"/>
-            <a:ext cx="4983480" cy="310896"/>
-          </a:xfrm>
-          <a:prstGeom prst="rect">
-            <a:avLst/>
-          </a:prstGeom>
-          <a:noFill/>
-        </p:spPr>
-        <p:txBody>
-          <a:bodyPr wrap="square" anchor="ctr" lIns="0" rIns="0" tIns="0" bIns="0">
-            <a:spAutoFit/>
-          </a:bodyPr>
-          <a:lstStyle/>
-          <a:p>
-            <a:pPr algn="l">
-              <a:lnSpc>
-                <a:spcPct val="100000"/>
-              </a:lnSpc>
-              <a:spcBef>
-                <a:spcPts val="0"/>
-              </a:spcBef>
-              <a:spcAft>
-                <a:spcPts val="400"/>
-              </a:spcAft>
-            </a:pPr>
-            <a:r>
-              <a:rPr sz="1150" b="0" i="0">
-                <a:solidFill>
-                  <a:srgbClr val="5C6B7A"/>
-                </a:solidFill>
-                <a:latin typeface="Segoe UI"/>
-              </a:rPr>
-              <a:t>rcTx  :  </a:t>
-            </a:r>
-            <a:r>
-              <a:rPr sz="1150" b="1" i="0">
-                <a:solidFill>
-                  <a:srgbClr val="0F2540"/>
-                </a:solidFill>
-                <a:latin typeface="Segoe UI"/>
-              </a:rPr>
-              <a:t>RcTx</a:t>
-            </a:r>
-          </a:p>
-        </p:txBody>
-      </p:sp>
-      <p:sp>
-        <p:nvSpPr>
-          <p:cNvPr id="39" name="TextBox 38"/>
-          <p:cNvSpPr txBox="1"/>
-          <p:nvPr/>
-        </p:nvSpPr>
-        <p:spPr>
-          <a:xfrm>
-            <a:off x="6464808" y="4041648"/>
-            <a:ext cx="4983480" cy="310896"/>
-          </a:xfrm>
-          <a:prstGeom prst="rect">
-            <a:avLst/>
-          </a:prstGeom>
-          <a:noFill/>
-        </p:spPr>
-        <p:txBody>
-          <a:bodyPr wrap="square" anchor="ctr" lIns="0" rIns="0" tIns="0" bIns="0">
-            <a:spAutoFit/>
-          </a:bodyPr>
-          <a:lstStyle/>
-          <a:p>
-            <a:pPr algn="l">
-              <a:lnSpc>
-                <a:spcPct val="100000"/>
-              </a:lnSpc>
-              <a:spcBef>
-                <a:spcPts val="0"/>
-              </a:spcBef>
-              <a:spcAft>
-                <a:spcPts val="400"/>
-              </a:spcAft>
-            </a:pPr>
-            <a:r>
-              <a:rPr sz="1150" b="0" i="0">
-                <a:solidFill>
-                  <a:srgbClr val="5C6B7A"/>
-                </a:solidFill>
-                <a:latin typeface="Segoe UI"/>
-              </a:rPr>
-              <a:t>laptopLink  :  </a:t>
-            </a:r>
-            <a:r>
-              <a:rPr sz="1150" b="1" i="0">
-                <a:solidFill>
-                  <a:srgbClr val="0F2540"/>
-                </a:solidFill>
-                <a:latin typeface="Segoe UI"/>
-              </a:rPr>
-              <a:t>TelemetryGroundLink</a:t>
-            </a:r>
-          </a:p>
-        </p:txBody>
-      </p:sp>
-      <p:sp>
-        <p:nvSpPr>
-          <p:cNvPr id="40" name="TextBox 39"/>
-          <p:cNvSpPr txBox="1"/>
-          <p:nvPr/>
-        </p:nvSpPr>
-        <p:spPr>
-          <a:xfrm>
-            <a:off x="6464808" y="4352544"/>
-            <a:ext cx="4983480" cy="310896"/>
-          </a:xfrm>
-          <a:prstGeom prst="rect">
-            <a:avLst/>
-          </a:prstGeom>
-          <a:noFill/>
-        </p:spPr>
-        <p:txBody>
-          <a:bodyPr wrap="square" anchor="ctr" lIns="0" rIns="0" tIns="0" bIns="0">
-            <a:spAutoFit/>
-          </a:bodyPr>
-          <a:lstStyle/>
-          <a:p>
-            <a:pPr algn="l">
-              <a:lnSpc>
-                <a:spcPct val="100000"/>
-              </a:lnSpc>
-              <a:spcBef>
-                <a:spcPts val="0"/>
-              </a:spcBef>
-              <a:spcAft>
-                <a:spcPts val="400"/>
-              </a:spcAft>
-            </a:pPr>
-            <a:r>
-              <a:rPr sz="1150" b="0" i="0">
-                <a:solidFill>
-                  <a:srgbClr val="5C6B7A"/>
-                </a:solidFill>
-                <a:latin typeface="Segoe UI"/>
-              </a:rPr>
-              <a:t>groundAntenna  :  </a:t>
-            </a:r>
-            <a:r>
-              <a:rPr sz="1150" b="1" i="0">
-                <a:solidFill>
-                  <a:srgbClr val="0F2540"/>
-                </a:solidFill>
-                <a:latin typeface="Segoe UI"/>
-              </a:rPr>
-              <a:t>Antenna</a:t>
-            </a:r>
-          </a:p>
-        </p:txBody>
-      </p:sp>
-      <p:sp>
-        <p:nvSpPr>
-          <p:cNvPr id="41" name="TextBox 40"/>
-          <p:cNvSpPr txBox="1"/>
-          <p:nvPr/>
-        </p:nvSpPr>
-        <p:spPr>
-          <a:xfrm>
-            <a:off x="6464808" y="4663440"/>
-            <a:ext cx="4983480" cy="310896"/>
-          </a:xfrm>
-          <a:prstGeom prst="rect">
-            <a:avLst/>
-          </a:prstGeom>
-          <a:noFill/>
-        </p:spPr>
-        <p:txBody>
-          <a:bodyPr wrap="square" anchor="ctr" lIns="0" rIns="0" tIns="0" bIns="0">
-            <a:spAutoFit/>
-          </a:bodyPr>
-          <a:lstStyle/>
-          <a:p>
-            <a:pPr algn="l">
-              <a:lnSpc>
-                <a:spcPct val="100000"/>
-              </a:lnSpc>
-              <a:spcBef>
-                <a:spcPts val="0"/>
-              </a:spcBef>
-              <a:spcAft>
-                <a:spcPts val="400"/>
-              </a:spcAft>
-            </a:pPr>
-            <a:r>
-              <a:rPr sz="1150" b="0" i="0">
-                <a:solidFill>
-                  <a:srgbClr val="5C6B7A"/>
-                </a:solidFill>
-                <a:latin typeface="Segoe UI"/>
-              </a:rPr>
-              <a:t>charger  :  </a:t>
-            </a:r>
-            <a:r>
-              <a:rPr sz="1150" b="1" i="0">
-                <a:solidFill>
-                  <a:srgbClr val="0F2540"/>
-                </a:solidFill>
-                <a:latin typeface="Segoe UI"/>
-              </a:rPr>
-              <a:t>Charger</a:t>
-            </a:r>
-          </a:p>
-        </p:txBody>
-      </p:sp>
-      <p:sp>
-        <p:nvSpPr>
-          <p:cNvPr id="42" name="TextBox 41"/>
-          <p:cNvSpPr txBox="1"/>
-          <p:nvPr/>
-        </p:nvSpPr>
-        <p:spPr>
-          <a:xfrm>
-            <a:off x="566928" y="6236208"/>
-            <a:ext cx="11055096" cy="365760"/>
-          </a:xfrm>
-          <a:prstGeom prst="rect">
-            <a:avLst/>
-          </a:prstGeom>
-          <a:noFill/>
-        </p:spPr>
-        <p:txBody>
-          <a:bodyPr wrap="square" anchor="t" lIns="0" rIns="0" tIns="0" bIns="0">
-            <a:spAutoFit/>
-          </a:bodyPr>
-          <a:lstStyle/>
-          <a:p>
-            <a:pPr algn="l">
-              <a:lnSpc>
-                <a:spcPct val="100000"/>
-              </a:lnSpc>
-              <a:spcBef>
-                <a:spcPts val="0"/>
-              </a:spcBef>
-              <a:spcAft>
-                <a:spcPts val="400"/>
-              </a:spcAft>
-            </a:pPr>
-            <a:r>
-              <a:rPr sz="1000" b="0" i="0">
-                <a:solidFill>
-                  <a:srgbClr val="5C6B7A"/>
-                </a:solidFill>
-                <a:latin typeface="Segoe UI"/>
-              </a:rPr>
-              <a:t>Block-definition (composition) view — the SysML v2 analog of a BDD: each </a:t>
-            </a:r>
-            <a:r>
-              <a:rPr sz="1000" b="1" i="0">
-                <a:solidFill>
-                  <a:srgbClr val="5C6B7A"/>
-                </a:solidFill>
-                <a:latin typeface="Segoe UI"/>
-              </a:rPr>
-              <a:t>part def</a:t>
-            </a:r>
-            <a:r>
-              <a:rPr sz="1000" b="0" i="0">
-                <a:solidFill>
-                  <a:srgbClr val="5C6B7A"/>
-                </a:solidFill>
-                <a:latin typeface="Segoe UI"/>
-              </a:rPr>
-              <a:t> and the typed </a:t>
-            </a:r>
-            <a:r>
-              <a:rPr sz="1000" b="1" i="0">
-                <a:solidFill>
-                  <a:srgbClr val="5C6B7A"/>
-                </a:solidFill>
-                <a:latin typeface="Segoe UI"/>
-              </a:rPr>
-              <a:t>part</a:t>
-            </a:r>
-            <a:r>
-              <a:rPr sz="1000" b="0" i="0">
-                <a:solidFill>
-                  <a:srgbClr val="5C6B7A"/>
-                </a:solidFill>
-                <a:latin typeface="Segoe UI"/>
-              </a:rPr>
               <a:t> usages it composes. Phase-4 OpenHD parts (air/ground Wi-Fi adapters + antennas) omitted for the committed build.</a:t>
             </a:r>
           </a:p>
         </p:txBody>
       </p:sp>
+      <p:pic>
+        <p:nvPicPr>
+          <p:cNvPr id="43" name="Picture 42" descr="aos_syson.png"/>
+          <p:cNvPicPr>
+            <a:picLocks noChangeAspect="1"/>
+          </p:cNvPicPr>
+          <p:nvPr/>
+        </p:nvPicPr>
+        <p:blipFill>
+          <a:blip r:embed="rId3"/>
+          <a:stretch>
+            <a:fillRect/>
+          </a:stretch>
+        </p:blipFill>
+        <p:spPr>
+          <a:xfrm>
+            <a:off x="4487208" y="1005840"/>
+            <a:ext cx="3217278" cy="4480560"/>
+          </a:xfrm>
+          <a:prstGeom prst="rect">
+            <a:avLst/>
+          </a:prstGeom>
+        </p:spPr>
+      </p:pic>
     </p:spTree>
   </p:cSld>
   <p:clrMapOvr>

</xml_diff>

<commit_message>
Verify CDR deck for Lisa briefing; make slide 14 diagram native in build_cdr.py
- verify_cdr_deck.py: automated pre-briefing checks (slide 14 diagram present
  byte-identical, legacy hand-drawn shapes gone, caption/title preserved, no
  dangling rels, RTM table has no blank verification cells). All PASS.
- build_cdr.py: slide 14 now emits system_composition.png natively instead of
  hand-drawn sysml_box/def_panel shapes, so rebuilds no longer clobber the
  Sep 15 diagram swap; PROJ root now resolves from __file__ on either checkout.
- Regenerated deck (41 slides): also picks up R3_BHV_SBC_FAILSAFE, R3_CAM_COST
  600->720 restatement, and open-items RESOLVED/RETIRED rows that the Sep 15
  deck was missing. 35/41 slides text-identical to prior deck.
- cdr_deck_verification.md: full verification report (task #85 prep item).
- Commit Oct 9 flight_time_model.py sweep outputs left unstaged.
</commit_message>
<xml_diff>
--- a/CDR_Thermal_Surveillance_Drone.pptx
+++ b/CDR_Thermal_Surveillance_Drone.pptx
@@ -7045,7 +7045,7 @@
         </p:nvGraphicFramePr>
         <p:xfrm>
           <a:off x="566928" y="1207008"/>
-          <a:ext cx="11055096" cy="3602736"/>
+          <a:ext cx="11055096" cy="3877056"/>
         </p:xfrm>
         <a:graphic>
           <a:graphicData uri="http://schemas.openxmlformats.org/drawingml/2006/table">
@@ -7355,7 +7355,7 @@
                           </a:solidFill>
                           <a:latin typeface="Segoe UI"/>
                         </a:rPr>
-                        <a:t>R4_AF_ASSY</a:t>
+                        <a:t>R3_BHV_SBC_FAILSAFE</a:t>
                       </a:r>
                     </a:p>
                   </a:txBody>
@@ -7378,7 +7378,7 @@
                           </a:solidFill>
                           <a:latin typeface="Segoe UI"/>
                         </a:rPr>
-                        <a:t>The airframe assembly shall minimize DIY soldering, preferring…</a:t>
+                        <a:t>The autonomous flight behavior shall revert to a safe,…</a:t>
                       </a:r>
                     </a:p>
                   </a:txBody>
@@ -7401,7 +7401,7 @@
                           </a:solidFill>
                           <a:latin typeface="Segoe UI"/>
                         </a:rPr>
-                        <a:t>R5</a:t>
+                        <a:t>R3</a:t>
                       </a:r>
                     </a:p>
                   </a:txBody>
@@ -7424,7 +7424,7 @@
                           </a:solidFill>
                           <a:latin typeface="Segoe UI"/>
                         </a:rPr>
-                        <a:t>Airframe</a:t>
+                        <a:t>fcSoftware</a:t>
                       </a:r>
                     </a:p>
                   </a:txBody>
@@ -7449,7 +7449,7 @@
                           </a:solidFill>
                           <a:latin typeface="Segoe UI"/>
                         </a:rPr>
-                        <a:t>R4_AF_COST</a:t>
+                        <a:t>R4_AF_ASSY</a:t>
                       </a:r>
                     </a:p>
                   </a:txBody>
@@ -7472,7 +7472,7 @@
                           </a:solidFill>
                           <a:latin typeface="Segoe UI"/>
                         </a:rPr>
-                        <a:t>The complete airframe subsystem cost (frame + motors + ESCs +…</a:t>
+                        <a:t>The airframe assembly shall minimize DIY soldering, preferring…</a:t>
                       </a:r>
                     </a:p>
                   </a:txBody>
@@ -7495,7 +7495,7 @@
                           </a:solidFill>
                           <a:latin typeface="Segoe UI"/>
                         </a:rPr>
-                        <a:t>R4</a:t>
+                        <a:t>R5</a:t>
                       </a:r>
                     </a:p>
                   </a:txBody>
@@ -7543,7 +7543,7 @@
                           </a:solidFill>
                           <a:latin typeface="Segoe UI"/>
                         </a:rPr>
-                        <a:t>R4_AF_LANDING</a:t>
+                        <a:t>R4_AF_COST</a:t>
                       </a:r>
                     </a:p>
                   </a:txBody>
@@ -7566,7 +7566,7 @@
                           </a:solidFill>
                           <a:latin typeface="Segoe UI"/>
                         </a:rPr>
-                        <a:t>The airframe shall provide landing gear or structural clearance of at…</a:t>
+                        <a:t>The complete airframe subsystem cost (frame + motors + ESCs +…</a:t>
                       </a:r>
                     </a:p>
                   </a:txBody>
@@ -7589,7 +7589,7 @@
                           </a:solidFill>
                           <a:latin typeface="Segoe UI"/>
                         </a:rPr>
-                        <a:t>—</a:t>
+                        <a:t>R4</a:t>
                       </a:r>
                     </a:p>
                   </a:txBody>
@@ -7637,7 +7637,7 @@
                           </a:solidFill>
                           <a:latin typeface="Segoe UI"/>
                         </a:rPr>
-                        <a:t>R4_AF_PAYLOAD</a:t>
+                        <a:t>R4_AF_LANDING</a:t>
                       </a:r>
                     </a:p>
                   </a:txBody>
@@ -7660,7 +7660,7 @@
                           </a:solidFill>
                           <a:latin typeface="Segoe UI"/>
                         </a:rPr>
-                        <a:t>The airframe (frame + motors + ESCs + propellers + power…</a:t>
+                        <a:t>The airframe shall provide landing gear or structural clearance of at…</a:t>
                       </a:r>
                     </a:p>
                   </a:txBody>
@@ -7731,7 +7731,7 @@
                           </a:solidFill>
                           <a:latin typeface="Segoe UI"/>
                         </a:rPr>
-                        <a:t>R4_AF_PROP_CFG</a:t>
+                        <a:t>R4_AF_PAYLOAD</a:t>
                       </a:r>
                     </a:p>
                   </a:txBody>
@@ -7754,7 +7754,7 @@
                           </a:solidFill>
                           <a:latin typeface="Segoe UI"/>
                         </a:rPr>
-                        <a:t>The airframe shall accommodate propeller diameters and motor mounting…</a:t>
+                        <a:t>The airframe (frame + motors + ESCs + propellers + power…</a:t>
                       </a:r>
                     </a:p>
                   </a:txBody>
@@ -7777,7 +7777,7 @@
                           </a:solidFill>
                           <a:latin typeface="Segoe UI"/>
                         </a:rPr>
-                        <a:t>R1,R2</a:t>
+                        <a:t>—</a:t>
                       </a:r>
                     </a:p>
                   </a:txBody>
@@ -7825,7 +7825,7 @@
                           </a:solidFill>
                           <a:latin typeface="Segoe UI"/>
                         </a:rPr>
-                        <a:t>R4_AF_PWR_DIST</a:t>
+                        <a:t>R4_AF_PROP_CFG</a:t>
                       </a:r>
                     </a:p>
                   </a:txBody>
@@ -7848,7 +7848,7 @@
                           </a:solidFill>
                           <a:latin typeface="Segoe UI"/>
                         </a:rPr>
-                        <a:t>The airframe's power distribution wiring and connectors shall supply…</a:t>
+                        <a:t>The airframe shall accommodate propeller diameters and motor mounting…</a:t>
                       </a:r>
                     </a:p>
                   </a:txBody>
@@ -7871,7 +7871,7 @@
                           </a:solidFill>
                           <a:latin typeface="Segoe UI"/>
                         </a:rPr>
-                        <a:t>—</a:t>
+                        <a:t>R1,R2</a:t>
                       </a:r>
                     </a:p>
                   </a:txBody>
@@ -7919,7 +7919,7 @@
                           </a:solidFill>
                           <a:latin typeface="Segoe UI"/>
                         </a:rPr>
-                        <a:t>R4_AF_STIFF</a:t>
+                        <a:t>R4_AF_PWR_DIST</a:t>
                       </a:r>
                     </a:p>
                   </a:txBody>
@@ -7942,7 +7942,7 @@
                           </a:solidFill>
                           <a:latin typeface="Segoe UI"/>
                         </a:rPr>
-                        <a:t>The airframe structure shall be sufficiently rigid to prevent…</a:t>
+                        <a:t>The airframe's power distribution wiring and connectors shall supply…</a:t>
                       </a:r>
                     </a:p>
                   </a:txBody>
@@ -7965,7 +7965,7 @@
                           </a:solidFill>
                           <a:latin typeface="Segoe UI"/>
                         </a:rPr>
-                        <a:t>R3</a:t>
+                        <a:t>—</a:t>
                       </a:r>
                     </a:p>
                   </a:txBody>
@@ -8013,7 +8013,7 @@
                           </a:solidFill>
                           <a:latin typeface="Segoe UI"/>
                         </a:rPr>
-                        <a:t>R4_AF_WT</a:t>
+                        <a:t>R4_AF_STIFF</a:t>
                       </a:r>
                     </a:p>
                   </a:txBody>
@@ -8036,7 +8036,7 @@
                           </a:solidFill>
                           <a:latin typeface="Segoe UI"/>
                         </a:rPr>
-                        <a:t>The bare airframe mass (frame only, excluding motors, ESCs, and…</a:t>
+                        <a:t>The airframe structure shall be sufficiently rigid to prevent…</a:t>
                       </a:r>
                     </a:p>
                   </a:txBody>
@@ -8059,7 +8059,7 @@
                           </a:solidFill>
                           <a:latin typeface="Segoe UI"/>
                         </a:rPr>
-                        <a:t>—</a:t>
+                        <a:t>R3</a:t>
                       </a:r>
                     </a:p>
                   </a:txBody>
@@ -8107,7 +8107,7 @@
                           </a:solidFill>
                           <a:latin typeface="Segoe UI"/>
                         </a:rPr>
-                        <a:t>R6_BHV_RTL_RESERVE</a:t>
+                        <a:t>R4_AF_WT</a:t>
                       </a:r>
                     </a:p>
                   </a:txBody>
@@ -8130,7 +8130,7 @@
                           </a:solidFill>
                           <a:latin typeface="Segoe UI"/>
                         </a:rPr>
-                        <a:t>The autonomous flight behavior shall command an automatic…</a:t>
+                        <a:t>The bare airframe mass (frame only, excluding motors, ESCs, and…</a:t>
                       </a:r>
                     </a:p>
                   </a:txBody>
@@ -8153,7 +8153,7 @@
                           </a:solidFill>
                           <a:latin typeface="Segoe UI"/>
                         </a:rPr>
-                        <a:t>R6</a:t>
+                        <a:t>—</a:t>
                       </a:r>
                     </a:p>
                   </a:txBody>
@@ -8176,7 +8176,7 @@
                           </a:solidFill>
                           <a:latin typeface="Segoe UI"/>
                         </a:rPr>
-                        <a:t>executeRtl, fcSoftware</a:t>
+                        <a:t>Airframe</a:t>
                       </a:r>
                     </a:p>
                   </a:txBody>
@@ -8201,13 +8201,107 @@
                           </a:solidFill>
                           <a:latin typeface="Segoe UI"/>
                         </a:rPr>
+                        <a:t>R6_BHV_RTL_RESERVE</a:t>
+                      </a:r>
+                    </a:p>
+                  </a:txBody>
+                  <a:tcPr marL="54864" marR="54864" marT="18288" marB="18288" anchor="ctr">
+                    <a:solidFill>
+                      <a:srgbClr val="F6F8FA"/>
+                    </a:solidFill>
+                  </a:tcPr>
+                </a:tc>
+                <a:tc>
+                  <a:txBody>
+                    <a:bodyPr wrap="square"/>
+                    <a:lstStyle/>
+                    <a:p>
+                      <a:pPr algn="l"/>
+                      <a:r>
+                        <a:rPr sz="900" b="0">
+                          <a:solidFill>
+                            <a:srgbClr val="1E2833"/>
+                          </a:solidFill>
+                          <a:latin typeface="Segoe UI"/>
+                        </a:rPr>
+                        <a:t>The autonomous flight behavior shall command an automatic…</a:t>
+                      </a:r>
+                    </a:p>
+                  </a:txBody>
+                  <a:tcPr marL="54864" marR="54864" marT="18288" marB="18288" anchor="ctr">
+                    <a:solidFill>
+                      <a:srgbClr val="F6F8FA"/>
+                    </a:solidFill>
+                  </a:tcPr>
+                </a:tc>
+                <a:tc>
+                  <a:txBody>
+                    <a:bodyPr wrap="square"/>
+                    <a:lstStyle/>
+                    <a:p>
+                      <a:pPr algn="ctr"/>
+                      <a:r>
+                        <a:rPr sz="900" b="0">
+                          <a:solidFill>
+                            <a:srgbClr val="1E2833"/>
+                          </a:solidFill>
+                          <a:latin typeface="Segoe UI"/>
+                        </a:rPr>
+                        <a:t>R6</a:t>
+                      </a:r>
+                    </a:p>
+                  </a:txBody>
+                  <a:tcPr marL="54864" marR="54864" marT="18288" marB="18288" anchor="ctr">
+                    <a:solidFill>
+                      <a:srgbClr val="F6F8FA"/>
+                    </a:solidFill>
+                  </a:tcPr>
+                </a:tc>
+                <a:tc>
+                  <a:txBody>
+                    <a:bodyPr wrap="square"/>
+                    <a:lstStyle/>
+                    <a:p>
+                      <a:pPr algn="l"/>
+                      <a:r>
+                        <a:rPr sz="900" b="0">
+                          <a:solidFill>
+                            <a:srgbClr val="1E2833"/>
+                          </a:solidFill>
+                          <a:latin typeface="Segoe UI"/>
+                        </a:rPr>
+                        <a:t>executeRtl, fcSoftware</a:t>
+                      </a:r>
+                    </a:p>
+                  </a:txBody>
+                  <a:tcPr marL="54864" marR="54864" marT="18288" marB="18288" anchor="ctr">
+                    <a:solidFill>
+                      <a:srgbClr val="F6F8FA"/>
+                    </a:solidFill>
+                  </a:tcPr>
+                </a:tc>
+              </a:tr>
+              <a:tr h="274320">
+                <a:tc>
+                  <a:txBody>
+                    <a:bodyPr wrap="square"/>
+                    <a:lstStyle/>
+                    <a:p>
+                      <a:pPr algn="l"/>
+                      <a:r>
+                        <a:rPr sz="900" b="0">
+                          <a:solidFill>
+                            <a:srgbClr val="1E2833"/>
+                          </a:solidFill>
+                          <a:latin typeface="Segoe UI"/>
+                        </a:rPr>
                         <a:t>R7_BHV_LINKLOSS_RTL</a:t>
                       </a:r>
                     </a:p>
                   </a:txBody>
                   <a:tcPr marL="54864" marR="54864" marT="18288" marB="18288" anchor="ctr">
                     <a:solidFill>
-                      <a:srgbClr val="F6F8FA"/>
+                      <a:srgbClr val="FFFFFF"/>
                     </a:solidFill>
                   </a:tcPr>
                 </a:tc>
@@ -8230,7 +8324,7 @@
                   </a:txBody>
                   <a:tcPr marL="54864" marR="54864" marT="18288" marB="18288" anchor="ctr">
                     <a:solidFill>
-                      <a:srgbClr val="F6F8FA"/>
+                      <a:srgbClr val="FFFFFF"/>
                     </a:solidFill>
                   </a:tcPr>
                 </a:tc>
@@ -8253,7 +8347,7 @@
                   </a:txBody>
                   <a:tcPr marL="54864" marR="54864" marT="18288" marB="18288" anchor="ctr">
                     <a:solidFill>
-                      <a:srgbClr val="F6F8FA"/>
+                      <a:srgbClr val="FFFFFF"/>
                     </a:solidFill>
                   </a:tcPr>
                 </a:tc>
@@ -8276,7 +8370,7 @@
                   </a:txBody>
                   <a:tcPr marL="54864" marR="54864" marT="18288" marB="18288" anchor="ctr">
                     <a:solidFill>
-                      <a:srgbClr val="F6F8FA"/>
+                      <a:srgbClr val="FFFFFF"/>
                     </a:solidFill>
                   </a:tcPr>
                 </a:tc>
@@ -8816,7 +8910,7 @@
                           </a:solidFill>
                           <a:latin typeface="Segoe UI"/>
                         </a:rPr>
-                        <a:t>The camera subsystem cost shall not exceed 600 USD.</a:t>
+                        <a:t>The camera subsystem cost shall not exceed 720 USD. Raised from the…</a:t>
                       </a:r>
                     </a:p>
                   </a:txBody>
@@ -8910,7 +9004,7 @@
                           </a:solidFill>
                           <a:latin typeface="Segoe UI"/>
                         </a:rPr>
-                        <a:t>The camera shall provide a horizontal field of view of at least 30…</a:t>
+                        <a:t>The thermal camera shall image a continuous across-track ground swath…</a:t>
                       </a:r>
                     </a:p>
                   </a:txBody>
@@ -8933,7 +9027,7 @@
                           </a:solidFill>
                           <a:latin typeface="Segoe UI"/>
                         </a:rPr>
-                        <a:t>R3</a:t>
+                        <a:t>R9</a:t>
                       </a:r>
                     </a:p>
                   </a:txBody>
@@ -10440,7 +10534,7 @@
         </p:nvGraphicFramePr>
         <p:xfrm>
           <a:off x="566928" y="1207008"/>
-          <a:ext cx="11055096" cy="4082796"/>
+          <a:ext cx="11055096" cy="4334256"/>
         </p:xfrm>
         <a:graphic>
           <a:graphicData uri="http://schemas.openxmlformats.org/drawingml/2006/table">
@@ -11032,7 +11126,7 @@
                           </a:solidFill>
                           <a:latin typeface="Segoe UI"/>
                         </a:rPr>
-                        <a:t>R4_GCS_TELEM</a:t>
+                        <a:t>R4_GCS_SWEEP_SPACING</a:t>
                       </a:r>
                     </a:p>
                   </a:txBody>
@@ -11055,7 +11149,7 @@
                           </a:solidFill>
                           <a:latin typeface="Segoe UI"/>
                         </a:rPr>
-                        <a:t>The GCS display shall present real-time drone telemetry data…</a:t>
+                        <a:t>The flight planning software shall generate survey routes whose…</a:t>
                       </a:r>
                     </a:p>
                   </a:txBody>
@@ -11078,7 +11172,7 @@
                           </a:solidFill>
                           <a:latin typeface="Segoe UI"/>
                         </a:rPr>
-                        <a:t>—</a:t>
+                        <a:t>R9</a:t>
                       </a:r>
                     </a:p>
                   </a:txBody>
@@ -11101,7 +11195,7 @@
                           </a:solidFill>
                           <a:latin typeface="Segoe UI"/>
                         </a:rPr>
-                        <a:t>GCS, RcTx, gcsApp,…</a:t>
+                        <a:t>planRoute</a:t>
                       </a:r>
                     </a:p>
                   </a:txBody>
@@ -11126,7 +11220,7 @@
                           </a:solidFill>
                           <a:latin typeface="Segoe UI"/>
                         </a:rPr>
-                        <a:t>R4_GCS_VIDEO_DISP</a:t>
+                        <a:t>R4_GCS_TELEM</a:t>
                       </a:r>
                     </a:p>
                   </a:txBody>
@@ -11149,7 +11243,7 @@
                           </a:solidFill>
                           <a:latin typeface="Segoe UI"/>
                         </a:rPr>
-                        <a:t>The GCS display shall render the thermal video feed at sufficient…</a:t>
+                        <a:t>The GCS display shall present real-time drone telemetry data…</a:t>
                       </a:r>
                     </a:p>
                   </a:txBody>
@@ -11172,7 +11266,7 @@
                           </a:solidFill>
                           <a:latin typeface="Segoe UI"/>
                         </a:rPr>
-                        <a:t>R3</a:t>
+                        <a:t>—</a:t>
                       </a:r>
                     </a:p>
                   </a:txBody>
@@ -11195,7 +11289,7 @@
                           </a:solidFill>
                           <a:latin typeface="Segoe UI"/>
                         </a:rPr>
-                        <a:t>GCS, OhdGndRx, OhdWifiTx,…</a:t>
+                        <a:t>GCS, RcTx, gcsApp,…</a:t>
                       </a:r>
                     </a:p>
                   </a:txBody>
@@ -11220,7 +11314,7 @@
                           </a:solidFill>
                           <a:latin typeface="Segoe UI"/>
                         </a:rPr>
-                        <a:t>R4_GCS_WT</a:t>
+                        <a:t>R4_GCS_VIDEO_DISP</a:t>
                       </a:r>
                     </a:p>
                   </a:txBody>
@@ -11243,7 +11337,7 @@
                           </a:solidFill>
                           <a:latin typeface="Segoe UI"/>
                         </a:rPr>
-                        <a:t>The GCS system (transmitter, display, antennas, battery) shall be…</a:t>
+                        <a:t>The GCS display shall render the thermal video feed at sufficient…</a:t>
                       </a:r>
                     </a:p>
                   </a:txBody>
@@ -11266,7 +11360,7 @@
                           </a:solidFill>
                           <a:latin typeface="Segoe UI"/>
                         </a:rPr>
-                        <a:t>—</a:t>
+                        <a:t>R3</a:t>
                       </a:r>
                     </a:p>
                   </a:txBody>
@@ -11289,7 +11383,7 @@
                           </a:solidFill>
                           <a:latin typeface="Segoe UI"/>
                         </a:rPr>
-                        <a:t>GCS</a:t>
+                        <a:t>GCS, OhdGndRx, OhdWifiTx,…</a:t>
                       </a:r>
                     </a:p>
                   </a:txBody>
@@ -11314,7 +11408,7 @@
                           </a:solidFill>
                           <a:latin typeface="Segoe UI"/>
                         </a:rPr>
-                        <a:t>R4_SBC_COST</a:t>
+                        <a:t>R4_GCS_WT</a:t>
                       </a:r>
                     </a:p>
                   </a:txBody>
@@ -11337,7 +11431,7 @@
                           </a:solidFill>
                           <a:latin typeface="Segoe UI"/>
                         </a:rPr>
-                        <a:t>The SBC cost shall not exceed 150 USD.</a:t>
+                        <a:t>The GCS system (transmitter, display, antennas, battery) shall be…</a:t>
                       </a:r>
                     </a:p>
                   </a:txBody>
@@ -11360,7 +11454,7 @@
                           </a:solidFill>
                           <a:latin typeface="Segoe UI"/>
                         </a:rPr>
-                        <a:t>R4</a:t>
+                        <a:t>—</a:t>
                       </a:r>
                     </a:p>
                   </a:txBody>
@@ -11383,7 +11477,7 @@
                           </a:solidFill>
                           <a:latin typeface="Segoe UI"/>
                         </a:rPr>
-                        <a:t>SBCPayload</a:t>
+                        <a:t>GCS</a:t>
                       </a:r>
                     </a:p>
                   </a:txBody>
@@ -11408,7 +11502,7 @@
                           </a:solidFill>
                           <a:latin typeface="Segoe UI"/>
                         </a:rPr>
-                        <a:t>R4_SBC_DATA_AF</a:t>
+                        <a:t>R4_SBC_COST</a:t>
                       </a:r>
                     </a:p>
                   </a:txBody>
@@ -11431,7 +11525,7 @@
                           </a:solidFill>
                           <a:latin typeface="Segoe UI"/>
                         </a:rPr>
-                        <a:t>The SBC shall exchange telemetry and status data with the flight…</a:t>
+                        <a:t>The SBC cost shall not exceed 150 USD.</a:t>
                       </a:r>
                     </a:p>
                   </a:txBody>
@@ -11454,7 +11548,7 @@
                           </a:solidFill>
                           <a:latin typeface="Segoe UI"/>
                         </a:rPr>
-                        <a:t>—</a:t>
+                        <a:t>R4</a:t>
                       </a:r>
                     </a:p>
                   </a:txBody>
@@ -11477,7 +11571,7 @@
                           </a:solidFill>
                           <a:latin typeface="Segoe UI"/>
                         </a:rPr>
-                        <a:t>SBCPayload, mavlinkRouter</a:t>
+                        <a:t>SBCPayload</a:t>
                       </a:r>
                     </a:p>
                   </a:txBody>
@@ -11502,7 +11596,7 @@
                           </a:solidFill>
                           <a:latin typeface="Segoe UI"/>
                         </a:rPr>
-                        <a:t>R4_SBC_PWR</a:t>
+                        <a:t>R4_SBC_DATA_AF</a:t>
                       </a:r>
                     </a:p>
                   </a:txBody>
@@ -11525,7 +11619,7 @@
                           </a:solidFill>
                           <a:latin typeface="Segoe UI"/>
                         </a:rPr>
-                        <a:t>The SBC shall consume no more than 10W average during continuous…</a:t>
+                        <a:t>The SBC shall exchange telemetry and status data with the flight…</a:t>
                       </a:r>
                     </a:p>
                   </a:txBody>
@@ -11571,7 +11665,7 @@
                           </a:solidFill>
                           <a:latin typeface="Segoe UI"/>
                         </a:rPr>
-                        <a:t>SBCPayload</a:t>
+                        <a:t>SBCPayload, mavlinkRouter</a:t>
                       </a:r>
                     </a:p>
                   </a:txBody>
@@ -11596,7 +11690,7 @@
                           </a:solidFill>
                           <a:latin typeface="Segoe UI"/>
                         </a:rPr>
-                        <a:t>R4_SBC_TEMP</a:t>
+                        <a:t>R4_SBC_PWR</a:t>
                       </a:r>
                     </a:p>
                   </a:txBody>
@@ -11619,7 +11713,7 @@
                           </a:solidFill>
                           <a:latin typeface="Segoe UI"/>
                         </a:rPr>
-                        <a:t>The SBC shall operate within the full environmental temperature range…</a:t>
+                        <a:t>The SBC shall consume no more than 10W average during continuous…</a:t>
                       </a:r>
                     </a:p>
                   </a:txBody>
@@ -11690,7 +11784,7 @@
                           </a:solidFill>
                           <a:latin typeface="Segoe UI"/>
                         </a:rPr>
-                        <a:t>R4_SBC_VIDEO_IN</a:t>
+                        <a:t>R4_SBC_TEMP</a:t>
                       </a:r>
                     </a:p>
                   </a:txBody>
@@ -11713,7 +11807,7 @@
                           </a:solidFill>
                           <a:latin typeface="Segoe UI"/>
                         </a:rPr>
-                        <a:t>The SBC shall accept a video input from the thermal camera that…</a:t>
+                        <a:t>The SBC shall operate within the full environmental temperature range…</a:t>
                       </a:r>
                     </a:p>
                   </a:txBody>
@@ -11784,7 +11878,7 @@
                           </a:solidFill>
                           <a:latin typeface="Segoe UI"/>
                         </a:rPr>
-                        <a:t>R4_SBC_VIDEO_PROC</a:t>
+                        <a:t>R4_SBC_VIDEO_IN</a:t>
                       </a:r>
                     </a:p>
                   </a:txBody>
@@ -11807,7 +11901,7 @@
                           </a:solidFill>
                           <a:latin typeface="Segoe UI"/>
                         </a:rPr>
-                        <a:t>The SBC shall process the incoming video stream for live transmission…</a:t>
+                        <a:t>The SBC shall accept a video input from the thermal camera that…</a:t>
                       </a:r>
                     </a:p>
                   </a:txBody>
@@ -11830,7 +11924,7 @@
                           </a:solidFill>
                           <a:latin typeface="Segoe UI"/>
                         </a:rPr>
-                        <a:t>R3</a:t>
+                        <a:t>—</a:t>
                       </a:r>
                     </a:p>
                   </a:txBody>
@@ -11878,13 +11972,107 @@
                           </a:solidFill>
                           <a:latin typeface="Segoe UI"/>
                         </a:rPr>
+                        <a:t>R4_SBC_VIDEO_PROC</a:t>
+                      </a:r>
+                    </a:p>
+                  </a:txBody>
+                  <a:tcPr marL="54864" marR="54864" marT="18288" marB="18288" anchor="ctr">
+                    <a:solidFill>
+                      <a:srgbClr val="FFFFFF"/>
+                    </a:solidFill>
+                  </a:tcPr>
+                </a:tc>
+                <a:tc>
+                  <a:txBody>
+                    <a:bodyPr wrap="square"/>
+                    <a:lstStyle/>
+                    <a:p>
+                      <a:pPr algn="l"/>
+                      <a:r>
+                        <a:rPr sz="900" b="0">
+                          <a:solidFill>
+                            <a:srgbClr val="1E2833"/>
+                          </a:solidFill>
+                          <a:latin typeface="Segoe UI"/>
+                        </a:rPr>
+                        <a:t>The SBC shall process the incoming video stream for live transmission…</a:t>
+                      </a:r>
+                    </a:p>
+                  </a:txBody>
+                  <a:tcPr marL="54864" marR="54864" marT="18288" marB="18288" anchor="ctr">
+                    <a:solidFill>
+                      <a:srgbClr val="FFFFFF"/>
+                    </a:solidFill>
+                  </a:tcPr>
+                </a:tc>
+                <a:tc>
+                  <a:txBody>
+                    <a:bodyPr wrap="square"/>
+                    <a:lstStyle/>
+                    <a:p>
+                      <a:pPr algn="ctr"/>
+                      <a:r>
+                        <a:rPr sz="900" b="0">
+                          <a:solidFill>
+                            <a:srgbClr val="1E2833"/>
+                          </a:solidFill>
+                          <a:latin typeface="Segoe UI"/>
+                        </a:rPr>
+                        <a:t>R3</a:t>
+                      </a:r>
+                    </a:p>
+                  </a:txBody>
+                  <a:tcPr marL="54864" marR="54864" marT="18288" marB="18288" anchor="ctr">
+                    <a:solidFill>
+                      <a:srgbClr val="FFFFFF"/>
+                    </a:solidFill>
+                  </a:tcPr>
+                </a:tc>
+                <a:tc>
+                  <a:txBody>
+                    <a:bodyPr wrap="square"/>
+                    <a:lstStyle/>
+                    <a:p>
+                      <a:pPr algn="l"/>
+                      <a:r>
+                        <a:rPr sz="900" b="0">
+                          <a:solidFill>
+                            <a:srgbClr val="1E2833"/>
+                          </a:solidFill>
+                          <a:latin typeface="Segoe UI"/>
+                        </a:rPr>
+                        <a:t>SBCPayload</a:t>
+                      </a:r>
+                    </a:p>
+                  </a:txBody>
+                  <a:tcPr marL="54864" marR="54864" marT="18288" marB="18288" anchor="ctr">
+                    <a:solidFill>
+                      <a:srgbClr val="FFFFFF"/>
+                    </a:solidFill>
+                  </a:tcPr>
+                </a:tc>
+              </a:tr>
+              <a:tr h="251460">
+                <a:tc>
+                  <a:txBody>
+                    <a:bodyPr wrap="square"/>
+                    <a:lstStyle/>
+                    <a:p>
+                      <a:pPr algn="l"/>
+                      <a:r>
+                        <a:rPr sz="900" b="0">
+                          <a:solidFill>
+                            <a:srgbClr val="1E2833"/>
+                          </a:solidFill>
+                          <a:latin typeface="Segoe UI"/>
+                        </a:rPr>
                         <a:t>R4_SBC_WT</a:t>
                       </a:r>
                     </a:p>
                   </a:txBody>
                   <a:tcPr marL="54864" marR="54864" marT="18288" marB="18288" anchor="ctr">
                     <a:solidFill>
-                      <a:srgbClr val="FFFFFF"/>
+                      <a:srgbClr val="F6F8FA"/>
                     </a:solidFill>
                   </a:tcPr>
                 </a:tc>
@@ -11907,7 +12095,7 @@
                   </a:txBody>
                   <a:tcPr marL="54864" marR="54864" marT="18288" marB="18288" anchor="ctr">
                     <a:solidFill>
-                      <a:srgbClr val="FFFFFF"/>
+                      <a:srgbClr val="F6F8FA"/>
                     </a:solidFill>
                   </a:tcPr>
                 </a:tc>
@@ -11930,7 +12118,7 @@
                   </a:txBody>
                   <a:tcPr marL="54864" marR="54864" marT="18288" marB="18288" anchor="ctr">
                     <a:solidFill>
-                      <a:srgbClr val="FFFFFF"/>
+                      <a:srgbClr val="F6F8FA"/>
                     </a:solidFill>
                   </a:tcPr>
                 </a:tc>
@@ -11953,7 +12141,7 @@
                   </a:txBody>
                   <a:tcPr marL="54864" marR="54864" marT="18288" marB="18288" anchor="ctr">
                     <a:solidFill>
-                      <a:srgbClr val="FFFFFF"/>
+                      <a:srgbClr val="F6F8FA"/>
                     </a:solidFill>
                   </a:tcPr>
                 </a:tc>
@@ -12580,7 +12768,77 @@
       </p:sp>
       <p:sp>
         <p:nvSpPr>
-          <p:cNvPr id="42" name="TextBox 41"/>
+          <p:cNvPr id="9" name="Rectangle 8"/>
+          <p:cNvSpPr/>
+          <p:nvPr/>
+        </p:nvSpPr>
+        <p:spPr>
+          <a:xfrm>
+            <a:off x="3857117" y="1280160"/>
+            <a:ext cx="3478021" cy="4800600"/>
+          </a:xfrm>
+          <a:prstGeom prst="rect">
+            <a:avLst/>
+          </a:prstGeom>
+          <a:solidFill>
+            <a:srgbClr val="FFFFFF"/>
+          </a:solidFill>
+          <a:ln w="12700">
+            <a:solidFill>
+              <a:srgbClr val="D4DDE4"/>
+            </a:solidFill>
+          </a:ln>
+          <a:effectLst/>
+        </p:spPr>
+        <p:style>
+          <a:lnRef idx="1">
+            <a:schemeClr val="accent1"/>
+          </a:lnRef>
+          <a:fillRef idx="3">
+            <a:schemeClr val="accent1"/>
+          </a:fillRef>
+          <a:effectRef idx="2">
+            <a:schemeClr val="accent1"/>
+          </a:effectRef>
+          <a:fontRef idx="minor">
+            <a:schemeClr val="lt1"/>
+          </a:fontRef>
+        </p:style>
+        <p:txBody>
+          <a:bodyPr rtlCol="0" anchor="ctr"/>
+          <a:lstStyle/>
+          <a:p>
+            <a:pPr algn="ctr"/>
+          </a:p>
+        </p:txBody>
+      </p:sp>
+      <p:pic>
+        <p:nvPicPr>
+          <p:cNvPr id="10" name="Picture 9" descr="system_composition.png"/>
+          <p:cNvPicPr>
+            <a:picLocks noChangeAspect="1"/>
+          </p:cNvPicPr>
+          <p:nvPr/>
+        </p:nvPicPr>
+        <p:blipFill>
+          <a:blip r:embed="rId2"/>
+          <a:stretch>
+            <a:fillRect/>
+          </a:stretch>
+        </p:blipFill>
+        <p:spPr>
+          <a:xfrm>
+            <a:off x="3911981" y="1335024"/>
+            <a:ext cx="3368293" cy="4690872"/>
+          </a:xfrm>
+          <a:prstGeom prst="rect">
+            <a:avLst/>
+          </a:prstGeom>
+        </p:spPr>
+      </p:pic>
+      <p:sp>
+        <p:nvSpPr>
+          <p:cNvPr id="11" name="TextBox 10"/>
           <p:cNvSpPr txBox="1"/>
           <p:nvPr/>
         </p:nvSpPr>
@@ -12659,30 +12917,6 @@
           </a:p>
         </p:txBody>
       </p:sp>
-      <p:pic>
-        <p:nvPicPr>
-          <p:cNvPr id="43" name="Picture 42" descr="aos_syson.png"/>
-          <p:cNvPicPr>
-            <a:picLocks noChangeAspect="1"/>
-          </p:cNvPicPr>
-          <p:nvPr/>
-        </p:nvPicPr>
-        <p:blipFill>
-          <a:blip r:embed="rId3"/>
-          <a:stretch>
-            <a:fillRect/>
-          </a:stretch>
-        </p:blipFill>
-        <p:spPr>
-          <a:xfrm>
-            <a:off x="4487208" y="1005840"/>
-            <a:ext cx="3217278" cy="4480560"/>
-          </a:xfrm>
-          <a:prstGeom prst="rect">
-            <a:avLst/>
-          </a:prstGeom>
-        </p:spPr>
-      </p:pic>
     </p:spTree>
   </p:cSld>
   <p:clrMapOvr>
@@ -44975,7 +45209,7 @@
                           </a:solidFill>
                           <a:latin typeface="Segoe UI"/>
                         </a:rPr>
-                        <a:t>FC firmware — resolved to ArduCopter, but issues log still marked OPEN</a:t>
+                        <a:t>FC firmware — reconciled in MODEL_ISSUES.md §B7 (RESOLVED)</a:t>
                       </a:r>
                     </a:p>
                   </a:txBody>
@@ -44994,11 +45228,11 @@
                       <a:r>
                         <a:rPr sz="1100" b="0">
                           <a:solidFill>
-                            <a:srgbClr val="2E86AB"/>
-                          </a:solidFill>
-                          <a:latin typeface="Segoe UI"/>
-                        </a:rPr>
-                        <a:t>Doc</a:t>
+                            <a:srgbClr val="1F3A5F"/>
+                          </a:solidFill>
+                          <a:latin typeface="Segoe UI"/>
+                        </a:rPr>
+                        <a:t>RESOLVED</a:t>
                       </a:r>
                     </a:p>
                   </a:txBody>
@@ -45021,7 +45255,7 @@
                           </a:solidFill>
                           <a:latin typeface="Segoe UI"/>
                         </a:rPr>
-                        <a:t>Reconcile MODEL_ISSUES.md §B7 with SELECTED_COMPONENTS</a:t>
+                        <a:t>Issues log updated 2026-08-09 to match SELECTED_COMPONENTS</a:t>
                       </a:r>
                     </a:p>
                   </a:txBody>
@@ -45207,11 +45441,11 @@
                       <a:r>
                         <a:rPr sz="1100" b="0">
                           <a:solidFill>
-                            <a:srgbClr val="D9821E"/>
-                          </a:solidFill>
-                          <a:latin typeface="Segoe UI"/>
-                        </a:rPr>
-                        <a:t>TBD</a:t>
+                            <a:srgbClr val="1F3A5F"/>
+                          </a:solidFill>
+                          <a:latin typeface="Segoe UI"/>
+                        </a:rPr>
+                        <a:t>RETIRED</a:t>
                       </a:r>
                     </a:p>
                   </a:txBody>
@@ -45234,7 +45468,7 @@
                           </a:solidFill>
                           <a:latin typeface="Segoe UI"/>
                         </a:rPr>
-                        <a:t>Close or remove; no effect on baseline</a:t>
+                        <a:t>Retired 2026-08-08 from candidates.sysml (see MODEL_ISSUES.md B4). No effect on baseline.</a:t>
                       </a:r>
                     </a:p>
                   </a:txBody>
@@ -48600,7 +48834,7 @@
                 </a:solidFill>
                 <a:latin typeface="Segoe UI"/>
               </a:rPr>
-              <a:t>8 requirements</a:t>
+              <a:t>9 requirements</a:t>
             </a:r>
           </a:p>
         </p:txBody>
@@ -48825,7 +49059,7 @@
                 </a:solidFill>
                 <a:latin typeface="Segoe UI"/>
               </a:rPr>
-              <a:t>4 requirements</a:t>
+              <a:t>5 requirements</a:t>
             </a:r>
           </a:p>
         </p:txBody>
@@ -51315,7 +51549,7 @@
                           </a:solidFill>
                           <a:latin typeface="Segoe UI"/>
                         </a:rPr>
-                        <a:t>2</a:t>
+                        <a:t>3</a:t>
                       </a:r>
                     </a:p>
                   </a:txBody>
@@ -51409,7 +51643,7 @@
                           </a:solidFill>
                           <a:latin typeface="Segoe UI"/>
                         </a:rPr>
-                        <a:t>2</a:t>
+                        <a:t>3</a:t>
                       </a:r>
                     </a:p>
                   </a:txBody>

</xml_diff>

<commit_message>
Reconcile CDR deck + prep to 18mm lens / 45-deg along-range; prep doc mapped to 41-slide deck
- build_cdr.py: slide 26 camera card 13mm->18mm; slide 30 Analysis 2 now uses
  as-built geometry (nadir GSD 6.0/8.0 cm @90/120m, along-range px at 45-deg
  mount: 4.2 recognize @90m, 3.1 detect @120m) matching model.sysml
  ThermalRecognitionCheck/DetectionCheck; method + interpretation text updated.
- cdr_briefing_prep.md: rewritten against physical 41-slide numbering; cost
  figure updated to ~$1,848 committed / 26% margin; open items per deck;
  R3_BHV_SBC_FAILSAFE; new slides 6/25/26/27/41 (exit assessment) covered.
- cdr_deck_verification.md: appended 2026-10-12 follow-up verification.
- Deck regenerated; verify_cdr_deck.py ALL CHECKS PASS.
</commit_message>
<xml_diff>
--- a/CDR_Thermal_Surveillance_Drone.pptx
+++ b/CDR_Thermal_Surveillance_Drone.pptx
@@ -24071,7 +24071,7 @@
                 </a:solidFill>
                 <a:latin typeface="Segoe UI"/>
               </a:rPr>
-              <a:t>640×512 · 12 µm · 13 mm · USB-UVC</a:t>
+              <a:t>640×512 · 12 µm · 18 mm · USB-UVC</a:t>
             </a:r>
           </a:p>
         </p:txBody>
@@ -29521,7 +29521,7 @@
                 </a:solidFill>
                 <a:latin typeface="Segoe UI"/>
               </a:rPr>
-              <a:t>Geometric optics: ground sample distance (GSD) from sensor pitch, lens, altitude → pixels-on-target vs. Johnson criteria (detect ≥ 1.5 px, recognize ≥ 4 px across the target's minimum dimension). </a:t>
+              <a:t>Geometric optics: ground sample distance (GSD) from sensor pitch, lens, altitude → pixels-on-target vs. Johnson criteria (detect ≥ 1.5 px, recognize ≥ 4 px across the target's minimum dimension). Pixels-on-target are ALONG-RANGE at the as-built 45° mount tilt (GSD ×2.0 vs nadir) — the binding axis; nadir would read ~2× higher. </a:t>
             </a:r>
             <a:r>
               <a:rPr sz="1050" b="1" i="0">
@@ -29666,7 +29666,7 @@
                           </a:solidFill>
                           <a:latin typeface="Segoe UI"/>
                         </a:rPr>
-                        <a:t>6.0</a:t>
+                        <a:t>4.2</a:t>
                       </a:r>
                     </a:p>
                   </a:txBody>
@@ -29737,7 +29737,7 @@
                           </a:solidFill>
                           <a:latin typeface="Segoe UI"/>
                         </a:rPr>
-                        <a:t>4.5</a:t>
+                        <a:t>3.1</a:t>
                       </a:r>
                     </a:p>
                   </a:txBody>
@@ -29760,7 +29760,7 @@
                           </a:solidFill>
                           <a:latin typeface="Segoe UI"/>
                         </a:rPr>
-                        <a:t>Recognize ✓</a:t>
+                        <a:t>Detect ✓</a:t>
                       </a:r>
                     </a:p>
                   </a:txBody>
@@ -29808,7 +29808,7 @@
                           </a:solidFill>
                           <a:latin typeface="Segoe UI"/>
                         </a:rPr>
-                        <a:t>4.5</a:t>
+                        <a:t>3.1</a:t>
                       </a:r>
                     </a:p>
                   </a:txBody>
@@ -29879,7 +29879,7 @@
                           </a:solidFill>
                           <a:latin typeface="Segoe UI"/>
                         </a:rPr>
-                        <a:t>6.0</a:t>
+                        <a:t>4.2</a:t>
                       </a:r>
                     </a:p>
                   </a:txBody>
@@ -29950,7 +29950,7 @@
                           </a:solidFill>
                           <a:latin typeface="Segoe UI"/>
                         </a:rPr>
-                        <a:t>6.0</a:t>
+                        <a:t>4.2</a:t>
                       </a:r>
                     </a:p>
                   </a:txBody>
@@ -30021,7 +30021,7 @@
                           </a:solidFill>
                           <a:latin typeface="Segoe UI"/>
                         </a:rPr>
-                        <a:t>2.7</a:t>
+                        <a:t>1.9</a:t>
                       </a:r>
                     </a:p>
                   </a:txBody>
@@ -30189,7 +30189,7 @@
                 </a:solidFill>
                 <a:latin typeface="Segoe UI"/>
               </a:rPr>
-              <a:t>8.3 cm</a:t>
+              <a:t>6.0 cm</a:t>
             </a:r>
           </a:p>
         </p:txBody>
@@ -30234,7 +30234,7 @@
                 </a:solidFill>
                 <a:latin typeface="Segoe UI"/>
               </a:rPr>
-              <a:t>GSD per pixel @ 90 m</a:t>
+              <a:t>Nadir GSD per pixel @ 90 m</a:t>
             </a:r>
           </a:p>
         </p:txBody>
@@ -30369,7 +30369,7 @@
                 </a:solidFill>
                 <a:latin typeface="Segoe UI"/>
               </a:rPr>
-              <a:t>11.1 cm</a:t>
+              <a:t>8.0 cm</a:t>
             </a:r>
           </a:p>
         </p:txBody>
@@ -30414,7 +30414,7 @@
                 </a:solidFill>
                 <a:latin typeface="Segoe UI"/>
               </a:rPr>
-              <a:t>GSD per pixel @ 120 m</a:t>
+              <a:t>Nadir GSD per pixel @ 120 m</a:t>
             </a:r>
           </a:p>
         </p:txBody>
@@ -30594,7 +30594,7 @@
                 </a:solidFill>
                 <a:latin typeface="Segoe UI"/>
               </a:rPr>
-              <a:t>Sensor, 12 µm pitch, 13 mm lens</a:t>
+              <a:t>Sensor, 12 µm pitch, 18 mm lens</a:t>
             </a:r>
           </a:p>
         </p:txBody>
@@ -30910,7 +30910,7 @@
                 </a:solidFill>
                 <a:latin typeface="Segoe UI"/>
               </a:rPr>
-              <a:t>Optics deliver detection-grade pixels-on-target for deer/human across 90–120 m and recognition-grade for a 0.5 m target. Robust species classification (R3.2) is the AI model's job and the key validation risk — confirmed by field thermal capture, not geometry alone.</a:t>
+              <a:t>Detection is comfortable across 90–120 m (3.1–4.2 px along-range at the 45° mount vs a 1.5 px floor). RECOGNITION of a 0.5 m target is the tightest margin in the thermal chain — ~4.2 px vs a 4 px floor at 90 m — so the as-built figure must be confirmed by field capture (task 2.17), not geometry alone. Species classification (R3.2) is the trained AI model's job.</a:t>
             </a:r>
           </a:p>
         </p:txBody>

</xml_diff>